<commit_message>
Add AWS/Azure service icon badges to architecture diagrams
- New inline SVG icon sprite (16 symbols: compute, database, storage,
  network, load balancer, security group, firewall/threat, key, identity,
  bastion/terminal, direct connect, transit hub, governance, isolation,
  DLP/scan, backup) colored by provider (AWS orange / Azure blue)
- Applied to Architecture zone-stack labels, Network Detail subnet cards,
  the AWS<->Azure terminology table, the Personal Credit Info security
  appliance table, and JIT Access step cards
- Mirrored as native PowerPoint shape+label badges in the PPTX deck
  (zoneDetailSlide, netTopologySlide, jitFlowSlide) — no external images,
  fully editable
</commit_message>
<xml_diff>
--- a/architecture/finance-multicloud-architecture.pptx
+++ b/architecture/finance-multicloud-architecture.pptx
@@ -10908,14 +10908,75 @@
       </p:sp>
       <p:sp>
         <p:nvSpPr>
-          <p:cNvPr id="12" name="Text 10"/>
+          <p:cNvPr id="12" name="Shape 10"/>
+          <p:cNvSpPr/>
+          <p:nvPr/>
+        </p:nvSpPr>
+        <p:spPr>
+          <a:xfrm>
+            <a:off x="649224" y="2907792"/>
+            <a:ext cx="201168" cy="201168"/>
+          </a:xfrm>
+          <a:prstGeom prst="roundRect">
+            <a:avLst>
+              <a:gd name="adj" fmla="val 28000"/>
+            </a:avLst>
+          </a:prstGeom>
+          <a:solidFill>
+            <a:srgbClr val="B5642A"/>
+          </a:solidFill>
+          <a:ln/>
+        </p:spPr>
+      </p:sp>
+      <p:sp>
+        <p:nvSpPr>
+          <p:cNvPr id="13" name="Text 11"/>
           <p:cNvSpPr txBox="1"/>
           <p:nvPr/>
         </p:nvSpPr>
         <p:spPr>
           <a:xfrm>
-            <a:off x="649224" y="2889504"/>
-            <a:ext cx="2284400" cy="384048"/>
+            <a:off x="649224" y="2907792"/>
+            <a:ext cx="201168" cy="201168"/>
+          </a:xfrm>
+          <a:prstGeom prst="rect">
+            <a:avLst/>
+          </a:prstGeom>
+          <a:noFill/>
+          <a:ln/>
+        </p:spPr>
+        <p:txBody>
+          <a:bodyPr wrap="square" lIns="0" tIns="0" rIns="0" bIns="0" rtlCol="0" anchor="ctr"/>
+          <a:lstStyle/>
+          <a:p>
+            <a:pPr algn="ctr" indent="0" marL="0">
+              <a:buNone/>
+            </a:pPr>
+            <a:r>
+              <a:rPr lang="en-US" sz="600" b="1" dirty="0">
+                <a:solidFill>
+                  <a:srgbClr val="FFFFFF"/>
+                </a:solidFill>
+                <a:latin typeface="Consolas" pitchFamily="34" charset="0"/>
+                <a:ea typeface="Consolas" pitchFamily="34" charset="-122"/>
+                <a:cs typeface="Consolas" pitchFamily="34" charset="-120"/>
+              </a:rPr>
+              <a:t>ID</a:t>
+            </a:r>
+            <a:endParaRPr lang="en-US" sz="600" dirty="0"/>
+          </a:p>
+        </p:txBody>
+      </p:sp>
+      <p:sp>
+        <p:nvSpPr>
+          <p:cNvPr id="14" name="Text 12"/>
+          <p:cNvSpPr txBox="1"/>
+          <p:nvPr/>
+        </p:nvSpPr>
+        <p:spPr>
+          <a:xfrm>
+            <a:off x="905256" y="2889504"/>
+            <a:ext cx="2028368" cy="384048"/>
           </a:xfrm>
           <a:prstGeom prst="rect">
             <a:avLst/>
@@ -10947,7 +11008,7 @@
       </p:sp>
       <p:sp>
         <p:nvSpPr>
-          <p:cNvPr id="13" name="Text 11"/>
+          <p:cNvPr id="15" name="Text 13"/>
           <p:cNvSpPr txBox="1"/>
           <p:nvPr/>
         </p:nvSpPr>
@@ -10989,7 +11050,7 @@
       </p:sp>
       <p:sp>
         <p:nvSpPr>
-          <p:cNvPr id="14" name="Text 12"/>
+          <p:cNvPr id="16" name="Text 14"/>
           <p:cNvSpPr txBox="1"/>
           <p:nvPr/>
         </p:nvSpPr>
@@ -11028,7 +11089,7 @@
       </p:sp>
       <p:sp>
         <p:nvSpPr>
-          <p:cNvPr id="15" name="Shape 13"/>
+          <p:cNvPr id="17" name="Shape 15"/>
           <p:cNvSpPr/>
           <p:nvPr/>
         </p:nvSpPr>
@@ -11062,7 +11123,7 @@
       </p:sp>
       <p:sp>
         <p:nvSpPr>
-          <p:cNvPr id="16" name="Text 14"/>
+          <p:cNvPr id="18" name="Text 16"/>
           <p:cNvSpPr txBox="1"/>
           <p:nvPr/>
         </p:nvSpPr>
@@ -11101,14 +11162,75 @@
       </p:sp>
       <p:sp>
         <p:nvSpPr>
-          <p:cNvPr id="17" name="Text 15"/>
+          <p:cNvPr id="19" name="Shape 17"/>
+          <p:cNvSpPr/>
+          <p:nvPr/>
+        </p:nvSpPr>
+        <p:spPr>
+          <a:xfrm>
+            <a:off x="3518840" y="2907792"/>
+            <a:ext cx="201168" cy="201168"/>
+          </a:xfrm>
+          <a:prstGeom prst="roundRect">
+            <a:avLst>
+              <a:gd name="adj" fmla="val 28000"/>
+            </a:avLst>
+          </a:prstGeom>
+          <a:solidFill>
+            <a:srgbClr val="B5642A"/>
+          </a:solidFill>
+          <a:ln/>
+        </p:spPr>
+      </p:sp>
+      <p:sp>
+        <p:nvSpPr>
+          <p:cNvPr id="20" name="Text 18"/>
           <p:cNvSpPr txBox="1"/>
           <p:nvPr/>
         </p:nvSpPr>
         <p:spPr>
           <a:xfrm>
-            <a:off x="3518840" y="2889504"/>
-            <a:ext cx="2284400" cy="384048"/>
+            <a:off x="3518840" y="2907792"/>
+            <a:ext cx="201168" cy="201168"/>
+          </a:xfrm>
+          <a:prstGeom prst="rect">
+            <a:avLst/>
+          </a:prstGeom>
+          <a:noFill/>
+          <a:ln/>
+        </p:spPr>
+        <p:txBody>
+          <a:bodyPr wrap="square" lIns="0" tIns="0" rIns="0" bIns="0" rtlCol="0" anchor="ctr"/>
+          <a:lstStyle/>
+          <a:p>
+            <a:pPr algn="ctr" indent="0" marL="0">
+              <a:buNone/>
+            </a:pPr>
+            <a:r>
+              <a:rPr lang="en-US" sz="600" b="1" dirty="0">
+                <a:solidFill>
+                  <a:srgbClr val="FFFFFF"/>
+                </a:solidFill>
+                <a:latin typeface="Consolas" pitchFamily="34" charset="0"/>
+                <a:ea typeface="Consolas" pitchFamily="34" charset="-122"/>
+                <a:cs typeface="Consolas" pitchFamily="34" charset="-120"/>
+              </a:rPr>
+              <a:t>KEY</a:t>
+            </a:r>
+            <a:endParaRPr lang="en-US" sz="600" dirty="0"/>
+          </a:p>
+        </p:txBody>
+      </p:sp>
+      <p:sp>
+        <p:nvSpPr>
+          <p:cNvPr id="21" name="Text 19"/>
+          <p:cNvSpPr txBox="1"/>
+          <p:nvPr/>
+        </p:nvSpPr>
+        <p:spPr>
+          <a:xfrm>
+            <a:off x="3774872" y="2889504"/>
+            <a:ext cx="2028368" cy="384048"/>
           </a:xfrm>
           <a:prstGeom prst="rect">
             <a:avLst/>
@@ -11140,7 +11262,7 @@
       </p:sp>
       <p:sp>
         <p:nvSpPr>
-          <p:cNvPr id="18" name="Text 16"/>
+          <p:cNvPr id="22" name="Text 20"/>
           <p:cNvSpPr txBox="1"/>
           <p:nvPr/>
         </p:nvSpPr>
@@ -11182,7 +11304,7 @@
       </p:sp>
       <p:sp>
         <p:nvSpPr>
-          <p:cNvPr id="19" name="Text 17"/>
+          <p:cNvPr id="23" name="Text 21"/>
           <p:cNvSpPr txBox="1"/>
           <p:nvPr/>
         </p:nvSpPr>
@@ -11221,7 +11343,7 @@
       </p:sp>
       <p:sp>
         <p:nvSpPr>
-          <p:cNvPr id="20" name="Shape 18"/>
+          <p:cNvPr id="24" name="Shape 22"/>
           <p:cNvSpPr/>
           <p:nvPr/>
         </p:nvSpPr>
@@ -11255,7 +11377,7 @@
       </p:sp>
       <p:sp>
         <p:nvSpPr>
-          <p:cNvPr id="21" name="Text 19"/>
+          <p:cNvPr id="25" name="Text 23"/>
           <p:cNvSpPr txBox="1"/>
           <p:nvPr/>
         </p:nvSpPr>
@@ -11294,14 +11416,75 @@
       </p:sp>
       <p:sp>
         <p:nvSpPr>
-          <p:cNvPr id="22" name="Text 20"/>
+          <p:cNvPr id="26" name="Shape 24"/>
+          <p:cNvSpPr/>
+          <p:nvPr/>
+        </p:nvSpPr>
+        <p:spPr>
+          <a:xfrm>
+            <a:off x="6388456" y="2907792"/>
+            <a:ext cx="201168" cy="201168"/>
+          </a:xfrm>
+          <a:prstGeom prst="roundRect">
+            <a:avLst>
+              <a:gd name="adj" fmla="val 28000"/>
+            </a:avLst>
+          </a:prstGeom>
+          <a:solidFill>
+            <a:srgbClr val="B5642A"/>
+          </a:solidFill>
+          <a:ln/>
+        </p:spPr>
+      </p:sp>
+      <p:sp>
+        <p:nvSpPr>
+          <p:cNvPr id="27" name="Text 25"/>
           <p:cNvSpPr txBox="1"/>
           <p:nvPr/>
         </p:nvSpPr>
         <p:spPr>
           <a:xfrm>
-            <a:off x="6388456" y="2889504"/>
-            <a:ext cx="2284400" cy="384048"/>
+            <a:off x="6388456" y="2907792"/>
+            <a:ext cx="201168" cy="201168"/>
+          </a:xfrm>
+          <a:prstGeom prst="rect">
+            <a:avLst/>
+          </a:prstGeom>
+          <a:noFill/>
+          <a:ln/>
+        </p:spPr>
+        <p:txBody>
+          <a:bodyPr wrap="square" lIns="0" tIns="0" rIns="0" bIns="0" rtlCol="0" anchor="ctr"/>
+          <a:lstStyle/>
+          <a:p>
+            <a:pPr algn="ctr" indent="0" marL="0">
+              <a:buNone/>
+            </a:pPr>
+            <a:r>
+              <a:rPr lang="en-US" sz="600" b="1" dirty="0">
+                <a:solidFill>
+                  <a:srgbClr val="FFFFFF"/>
+                </a:solidFill>
+                <a:latin typeface="Consolas" pitchFamily="34" charset="0"/>
+                <a:ea typeface="Consolas" pitchFamily="34" charset="-122"/>
+                <a:cs typeface="Consolas" pitchFamily="34" charset="-120"/>
+              </a:rPr>
+              <a:t>NET</a:t>
+            </a:r>
+            <a:endParaRPr lang="en-US" sz="600" dirty="0"/>
+          </a:p>
+        </p:txBody>
+      </p:sp>
+      <p:sp>
+        <p:nvSpPr>
+          <p:cNvPr id="28" name="Text 26"/>
+          <p:cNvSpPr txBox="1"/>
+          <p:nvPr/>
+        </p:nvSpPr>
+        <p:spPr>
+          <a:xfrm>
+            <a:off x="6644488" y="2889504"/>
+            <a:ext cx="2028368" cy="384048"/>
           </a:xfrm>
           <a:prstGeom prst="rect">
             <a:avLst/>
@@ -11333,7 +11516,7 @@
       </p:sp>
       <p:sp>
         <p:nvSpPr>
-          <p:cNvPr id="23" name="Text 21"/>
+          <p:cNvPr id="29" name="Text 27"/>
           <p:cNvSpPr txBox="1"/>
           <p:nvPr/>
         </p:nvSpPr>
@@ -11375,7 +11558,7 @@
       </p:sp>
       <p:sp>
         <p:nvSpPr>
-          <p:cNvPr id="24" name="Text 22"/>
+          <p:cNvPr id="30" name="Text 28"/>
           <p:cNvSpPr txBox="1"/>
           <p:nvPr/>
         </p:nvSpPr>
@@ -11414,7 +11597,7 @@
       </p:sp>
       <p:sp>
         <p:nvSpPr>
-          <p:cNvPr id="25" name="Shape 23"/>
+          <p:cNvPr id="31" name="Shape 29"/>
           <p:cNvSpPr/>
           <p:nvPr/>
         </p:nvSpPr>
@@ -11448,7 +11631,7 @@
       </p:sp>
       <p:sp>
         <p:nvSpPr>
-          <p:cNvPr id="26" name="Text 24"/>
+          <p:cNvPr id="32" name="Text 30"/>
           <p:cNvSpPr txBox="1"/>
           <p:nvPr/>
         </p:nvSpPr>
@@ -11487,14 +11670,75 @@
       </p:sp>
       <p:sp>
         <p:nvSpPr>
-          <p:cNvPr id="27" name="Text 25"/>
+          <p:cNvPr id="33" name="Shape 31"/>
+          <p:cNvSpPr/>
+          <p:nvPr/>
+        </p:nvSpPr>
+        <p:spPr>
+          <a:xfrm>
+            <a:off x="9258071" y="2907792"/>
+            <a:ext cx="201168" cy="201168"/>
+          </a:xfrm>
+          <a:prstGeom prst="roundRect">
+            <a:avLst>
+              <a:gd name="adj" fmla="val 28000"/>
+            </a:avLst>
+          </a:prstGeom>
+          <a:solidFill>
+            <a:srgbClr val="B5642A"/>
+          </a:solidFill>
+          <a:ln/>
+        </p:spPr>
+      </p:sp>
+      <p:sp>
+        <p:nvSpPr>
+          <p:cNvPr id="34" name="Text 32"/>
           <p:cNvSpPr txBox="1"/>
           <p:nvPr/>
         </p:nvSpPr>
         <p:spPr>
           <a:xfrm>
-            <a:off x="9258071" y="2889504"/>
-            <a:ext cx="2284400" cy="384048"/>
+            <a:off x="9258071" y="2907792"/>
+            <a:ext cx="201168" cy="201168"/>
+          </a:xfrm>
+          <a:prstGeom prst="rect">
+            <a:avLst/>
+          </a:prstGeom>
+          <a:noFill/>
+          <a:ln/>
+        </p:spPr>
+        <p:txBody>
+          <a:bodyPr wrap="square" lIns="0" tIns="0" rIns="0" bIns="0" rtlCol="0" anchor="ctr"/>
+          <a:lstStyle/>
+          <a:p>
+            <a:pPr algn="ctr" indent="0" marL="0">
+              <a:buNone/>
+            </a:pPr>
+            <a:r>
+              <a:rPr lang="en-US" sz="600" b="1" dirty="0">
+                <a:solidFill>
+                  <a:srgbClr val="FFFFFF"/>
+                </a:solidFill>
+                <a:latin typeface="Consolas" pitchFamily="34" charset="0"/>
+                <a:ea typeface="Consolas" pitchFamily="34" charset="-122"/>
+                <a:cs typeface="Consolas" pitchFamily="34" charset="-120"/>
+              </a:rPr>
+              <a:t>BAS</a:t>
+            </a:r>
+            <a:endParaRPr lang="en-US" sz="600" dirty="0"/>
+          </a:p>
+        </p:txBody>
+      </p:sp>
+      <p:sp>
+        <p:nvSpPr>
+          <p:cNvPr id="35" name="Text 33"/>
+          <p:cNvSpPr txBox="1"/>
+          <p:nvPr/>
+        </p:nvSpPr>
+        <p:spPr>
+          <a:xfrm>
+            <a:off x="9514103" y="2889504"/>
+            <a:ext cx="2028368" cy="384048"/>
           </a:xfrm>
           <a:prstGeom prst="rect">
             <a:avLst/>
@@ -11526,7 +11770,7 @@
       </p:sp>
       <p:sp>
         <p:nvSpPr>
-          <p:cNvPr id="28" name="Text 26"/>
+          <p:cNvPr id="36" name="Text 34"/>
           <p:cNvSpPr txBox="1"/>
           <p:nvPr/>
         </p:nvSpPr>
@@ -11568,7 +11812,7 @@
       </p:sp>
       <p:sp>
         <p:nvSpPr>
-          <p:cNvPr id="29" name="Text 27"/>
+          <p:cNvPr id="37" name="Text 35"/>
           <p:cNvSpPr txBox="1"/>
           <p:nvPr/>
         </p:nvSpPr>
@@ -12003,14 +12247,75 @@
       </p:sp>
       <p:sp>
         <p:nvSpPr>
-          <p:cNvPr id="12" name="Text 10"/>
+          <p:cNvPr id="12" name="Shape 10"/>
+          <p:cNvSpPr/>
+          <p:nvPr/>
+        </p:nvSpPr>
+        <p:spPr>
+          <a:xfrm>
+            <a:off x="649224" y="2907792"/>
+            <a:ext cx="201168" cy="201168"/>
+          </a:xfrm>
+          <a:prstGeom prst="roundRect">
+            <a:avLst>
+              <a:gd name="adj" fmla="val 28000"/>
+            </a:avLst>
+          </a:prstGeom>
+          <a:solidFill>
+            <a:srgbClr val="2E6DA4"/>
+          </a:solidFill>
+          <a:ln/>
+        </p:spPr>
+      </p:sp>
+      <p:sp>
+        <p:nvSpPr>
+          <p:cNvPr id="13" name="Text 11"/>
           <p:cNvSpPr txBox="1"/>
           <p:nvPr/>
         </p:nvSpPr>
         <p:spPr>
           <a:xfrm>
-            <a:off x="649224" y="2889504"/>
-            <a:ext cx="2284400" cy="384048"/>
+            <a:off x="649224" y="2907792"/>
+            <a:ext cx="201168" cy="201168"/>
+          </a:xfrm>
+          <a:prstGeom prst="rect">
+            <a:avLst/>
+          </a:prstGeom>
+          <a:noFill/>
+          <a:ln/>
+        </p:spPr>
+        <p:txBody>
+          <a:bodyPr wrap="square" lIns="0" tIns="0" rIns="0" bIns="0" rtlCol="0" anchor="ctr"/>
+          <a:lstStyle/>
+          <a:p>
+            <a:pPr algn="ctr" indent="0" marL="0">
+              <a:buNone/>
+            </a:pPr>
+            <a:r>
+              <a:rPr lang="en-US" sz="600" b="1" dirty="0">
+                <a:solidFill>
+                  <a:srgbClr val="FFFFFF"/>
+                </a:solidFill>
+                <a:latin typeface="Consolas" pitchFamily="34" charset="0"/>
+                <a:ea typeface="Consolas" pitchFamily="34" charset="-122"/>
+                <a:cs typeface="Consolas" pitchFamily="34" charset="-120"/>
+              </a:rPr>
+              <a:t>ID</a:t>
+            </a:r>
+            <a:endParaRPr lang="en-US" sz="600" dirty="0"/>
+          </a:p>
+        </p:txBody>
+      </p:sp>
+      <p:sp>
+        <p:nvSpPr>
+          <p:cNvPr id="14" name="Text 12"/>
+          <p:cNvSpPr txBox="1"/>
+          <p:nvPr/>
+        </p:nvSpPr>
+        <p:spPr>
+          <a:xfrm>
+            <a:off x="905256" y="2889504"/>
+            <a:ext cx="2028368" cy="384048"/>
           </a:xfrm>
           <a:prstGeom prst="rect">
             <a:avLst/>
@@ -12042,7 +12347,7 @@
       </p:sp>
       <p:sp>
         <p:nvSpPr>
-          <p:cNvPr id="13" name="Text 11"/>
+          <p:cNvPr id="15" name="Text 13"/>
           <p:cNvSpPr txBox="1"/>
           <p:nvPr/>
         </p:nvSpPr>
@@ -12084,7 +12389,7 @@
       </p:sp>
       <p:sp>
         <p:nvSpPr>
-          <p:cNvPr id="14" name="Text 12"/>
+          <p:cNvPr id="16" name="Text 14"/>
           <p:cNvSpPr txBox="1"/>
           <p:nvPr/>
         </p:nvSpPr>
@@ -12123,7 +12428,7 @@
       </p:sp>
       <p:sp>
         <p:nvSpPr>
-          <p:cNvPr id="15" name="Shape 13"/>
+          <p:cNvPr id="17" name="Shape 15"/>
           <p:cNvSpPr/>
           <p:nvPr/>
         </p:nvSpPr>
@@ -12157,7 +12462,7 @@
       </p:sp>
       <p:sp>
         <p:nvSpPr>
-          <p:cNvPr id="16" name="Text 14"/>
+          <p:cNvPr id="18" name="Text 16"/>
           <p:cNvSpPr txBox="1"/>
           <p:nvPr/>
         </p:nvSpPr>
@@ -12196,14 +12501,75 @@
       </p:sp>
       <p:sp>
         <p:nvSpPr>
-          <p:cNvPr id="17" name="Text 15"/>
+          <p:cNvPr id="19" name="Shape 17"/>
+          <p:cNvSpPr/>
+          <p:nvPr/>
+        </p:nvSpPr>
+        <p:spPr>
+          <a:xfrm>
+            <a:off x="3518840" y="2907792"/>
+            <a:ext cx="201168" cy="201168"/>
+          </a:xfrm>
+          <a:prstGeom prst="roundRect">
+            <a:avLst>
+              <a:gd name="adj" fmla="val 28000"/>
+            </a:avLst>
+          </a:prstGeom>
+          <a:solidFill>
+            <a:srgbClr val="2E6DA4"/>
+          </a:solidFill>
+          <a:ln/>
+        </p:spPr>
+      </p:sp>
+      <p:sp>
+        <p:nvSpPr>
+          <p:cNvPr id="20" name="Text 18"/>
           <p:cNvSpPr txBox="1"/>
           <p:nvPr/>
         </p:nvSpPr>
         <p:spPr>
           <a:xfrm>
-            <a:off x="3518840" y="2889504"/>
-            <a:ext cx="2284400" cy="384048"/>
+            <a:off x="3518840" y="2907792"/>
+            <a:ext cx="201168" cy="201168"/>
+          </a:xfrm>
+          <a:prstGeom prst="rect">
+            <a:avLst/>
+          </a:prstGeom>
+          <a:noFill/>
+          <a:ln/>
+        </p:spPr>
+        <p:txBody>
+          <a:bodyPr wrap="square" lIns="0" tIns="0" rIns="0" bIns="0" rtlCol="0" anchor="ctr"/>
+          <a:lstStyle/>
+          <a:p>
+            <a:pPr algn="ctr" indent="0" marL="0">
+              <a:buNone/>
+            </a:pPr>
+            <a:r>
+              <a:rPr lang="en-US" sz="600" b="1" dirty="0">
+                <a:solidFill>
+                  <a:srgbClr val="FFFFFF"/>
+                </a:solidFill>
+                <a:latin typeface="Consolas" pitchFamily="34" charset="0"/>
+                <a:ea typeface="Consolas" pitchFamily="34" charset="-122"/>
+                <a:cs typeface="Consolas" pitchFamily="34" charset="-120"/>
+              </a:rPr>
+              <a:t>KEY</a:t>
+            </a:r>
+            <a:endParaRPr lang="en-US" sz="600" dirty="0"/>
+          </a:p>
+        </p:txBody>
+      </p:sp>
+      <p:sp>
+        <p:nvSpPr>
+          <p:cNvPr id="21" name="Text 19"/>
+          <p:cNvSpPr txBox="1"/>
+          <p:nvPr/>
+        </p:nvSpPr>
+        <p:spPr>
+          <a:xfrm>
+            <a:off x="3774872" y="2889504"/>
+            <a:ext cx="2028368" cy="384048"/>
           </a:xfrm>
           <a:prstGeom prst="rect">
             <a:avLst/>
@@ -12235,7 +12601,7 @@
       </p:sp>
       <p:sp>
         <p:nvSpPr>
-          <p:cNvPr id="18" name="Text 16"/>
+          <p:cNvPr id="22" name="Text 20"/>
           <p:cNvSpPr txBox="1"/>
           <p:nvPr/>
         </p:nvSpPr>
@@ -12277,7 +12643,7 @@
       </p:sp>
       <p:sp>
         <p:nvSpPr>
-          <p:cNvPr id="19" name="Text 17"/>
+          <p:cNvPr id="23" name="Text 21"/>
           <p:cNvSpPr txBox="1"/>
           <p:nvPr/>
         </p:nvSpPr>
@@ -12316,7 +12682,7 @@
       </p:sp>
       <p:sp>
         <p:nvSpPr>
-          <p:cNvPr id="20" name="Shape 18"/>
+          <p:cNvPr id="24" name="Shape 22"/>
           <p:cNvSpPr/>
           <p:nvPr/>
         </p:nvSpPr>
@@ -12350,7 +12716,7 @@
       </p:sp>
       <p:sp>
         <p:nvSpPr>
-          <p:cNvPr id="21" name="Text 19"/>
+          <p:cNvPr id="25" name="Text 23"/>
           <p:cNvSpPr txBox="1"/>
           <p:nvPr/>
         </p:nvSpPr>
@@ -12389,14 +12755,75 @@
       </p:sp>
       <p:sp>
         <p:nvSpPr>
-          <p:cNvPr id="22" name="Text 20"/>
+          <p:cNvPr id="26" name="Shape 24"/>
+          <p:cNvSpPr/>
+          <p:nvPr/>
+        </p:nvSpPr>
+        <p:spPr>
+          <a:xfrm>
+            <a:off x="6388456" y="2907792"/>
+            <a:ext cx="201168" cy="201168"/>
+          </a:xfrm>
+          <a:prstGeom prst="roundRect">
+            <a:avLst>
+              <a:gd name="adj" fmla="val 28000"/>
+            </a:avLst>
+          </a:prstGeom>
+          <a:solidFill>
+            <a:srgbClr val="2E6DA4"/>
+          </a:solidFill>
+          <a:ln/>
+        </p:spPr>
+      </p:sp>
+      <p:sp>
+        <p:nvSpPr>
+          <p:cNvPr id="27" name="Text 25"/>
           <p:cNvSpPr txBox="1"/>
           <p:nvPr/>
         </p:nvSpPr>
         <p:spPr>
           <a:xfrm>
-            <a:off x="6388456" y="2889504"/>
-            <a:ext cx="2284400" cy="384048"/>
+            <a:off x="6388456" y="2907792"/>
+            <a:ext cx="201168" cy="201168"/>
+          </a:xfrm>
+          <a:prstGeom prst="rect">
+            <a:avLst/>
+          </a:prstGeom>
+          <a:noFill/>
+          <a:ln/>
+        </p:spPr>
+        <p:txBody>
+          <a:bodyPr wrap="square" lIns="0" tIns="0" rIns="0" bIns="0" rtlCol="0" anchor="ctr"/>
+          <a:lstStyle/>
+          <a:p>
+            <a:pPr algn="ctr" indent="0" marL="0">
+              <a:buNone/>
+            </a:pPr>
+            <a:r>
+              <a:rPr lang="en-US" sz="600" b="1" dirty="0">
+                <a:solidFill>
+                  <a:srgbClr val="FFFFFF"/>
+                </a:solidFill>
+                <a:latin typeface="Consolas" pitchFamily="34" charset="0"/>
+                <a:ea typeface="Consolas" pitchFamily="34" charset="-122"/>
+                <a:cs typeface="Consolas" pitchFamily="34" charset="-120"/>
+              </a:rPr>
+              <a:t>NET</a:t>
+            </a:r>
+            <a:endParaRPr lang="en-US" sz="600" dirty="0"/>
+          </a:p>
+        </p:txBody>
+      </p:sp>
+      <p:sp>
+        <p:nvSpPr>
+          <p:cNvPr id="28" name="Text 26"/>
+          <p:cNvSpPr txBox="1"/>
+          <p:nvPr/>
+        </p:nvSpPr>
+        <p:spPr>
+          <a:xfrm>
+            <a:off x="6644488" y="2889504"/>
+            <a:ext cx="2028368" cy="384048"/>
           </a:xfrm>
           <a:prstGeom prst="rect">
             <a:avLst/>
@@ -12428,7 +12855,7 @@
       </p:sp>
       <p:sp>
         <p:nvSpPr>
-          <p:cNvPr id="23" name="Text 21"/>
+          <p:cNvPr id="29" name="Text 27"/>
           <p:cNvSpPr txBox="1"/>
           <p:nvPr/>
         </p:nvSpPr>
@@ -12470,7 +12897,7 @@
       </p:sp>
       <p:sp>
         <p:nvSpPr>
-          <p:cNvPr id="24" name="Text 22"/>
+          <p:cNvPr id="30" name="Text 28"/>
           <p:cNvSpPr txBox="1"/>
           <p:nvPr/>
         </p:nvSpPr>
@@ -12509,7 +12936,7 @@
       </p:sp>
       <p:sp>
         <p:nvSpPr>
-          <p:cNvPr id="25" name="Shape 23"/>
+          <p:cNvPr id="31" name="Shape 29"/>
           <p:cNvSpPr/>
           <p:nvPr/>
         </p:nvSpPr>
@@ -12543,7 +12970,7 @@
       </p:sp>
       <p:sp>
         <p:nvSpPr>
-          <p:cNvPr id="26" name="Text 24"/>
+          <p:cNvPr id="32" name="Text 30"/>
           <p:cNvSpPr txBox="1"/>
           <p:nvPr/>
         </p:nvSpPr>
@@ -12582,14 +13009,75 @@
       </p:sp>
       <p:sp>
         <p:nvSpPr>
-          <p:cNvPr id="27" name="Text 25"/>
+          <p:cNvPr id="33" name="Shape 31"/>
+          <p:cNvSpPr/>
+          <p:nvPr/>
+        </p:nvSpPr>
+        <p:spPr>
+          <a:xfrm>
+            <a:off x="9258071" y="2907792"/>
+            <a:ext cx="201168" cy="201168"/>
+          </a:xfrm>
+          <a:prstGeom prst="roundRect">
+            <a:avLst>
+              <a:gd name="adj" fmla="val 28000"/>
+            </a:avLst>
+          </a:prstGeom>
+          <a:solidFill>
+            <a:srgbClr val="2E6DA4"/>
+          </a:solidFill>
+          <a:ln/>
+        </p:spPr>
+      </p:sp>
+      <p:sp>
+        <p:nvSpPr>
+          <p:cNvPr id="34" name="Text 32"/>
           <p:cNvSpPr txBox="1"/>
           <p:nvPr/>
         </p:nvSpPr>
         <p:spPr>
           <a:xfrm>
-            <a:off x="9258071" y="2889504"/>
-            <a:ext cx="2284400" cy="384048"/>
+            <a:off x="9258071" y="2907792"/>
+            <a:ext cx="201168" cy="201168"/>
+          </a:xfrm>
+          <a:prstGeom prst="rect">
+            <a:avLst/>
+          </a:prstGeom>
+          <a:noFill/>
+          <a:ln/>
+        </p:spPr>
+        <p:txBody>
+          <a:bodyPr wrap="square" lIns="0" tIns="0" rIns="0" bIns="0" rtlCol="0" anchor="ctr"/>
+          <a:lstStyle/>
+          <a:p>
+            <a:pPr algn="ctr" indent="0" marL="0">
+              <a:buNone/>
+            </a:pPr>
+            <a:r>
+              <a:rPr lang="en-US" sz="600" b="1" dirty="0">
+                <a:solidFill>
+                  <a:srgbClr val="FFFFFF"/>
+                </a:solidFill>
+                <a:latin typeface="Consolas" pitchFamily="34" charset="0"/>
+                <a:ea typeface="Consolas" pitchFamily="34" charset="-122"/>
+                <a:cs typeface="Consolas" pitchFamily="34" charset="-120"/>
+              </a:rPr>
+              <a:t>BAS</a:t>
+            </a:r>
+            <a:endParaRPr lang="en-US" sz="600" dirty="0"/>
+          </a:p>
+        </p:txBody>
+      </p:sp>
+      <p:sp>
+        <p:nvSpPr>
+          <p:cNvPr id="35" name="Text 33"/>
+          <p:cNvSpPr txBox="1"/>
+          <p:nvPr/>
+        </p:nvSpPr>
+        <p:spPr>
+          <a:xfrm>
+            <a:off x="9514103" y="2889504"/>
+            <a:ext cx="2028368" cy="384048"/>
           </a:xfrm>
           <a:prstGeom prst="rect">
             <a:avLst/>
@@ -12621,7 +13109,7 @@
       </p:sp>
       <p:sp>
         <p:nvSpPr>
-          <p:cNvPr id="28" name="Text 26"/>
+          <p:cNvPr id="36" name="Text 34"/>
           <p:cNvSpPr txBox="1"/>
           <p:nvPr/>
         </p:nvSpPr>
@@ -12663,7 +13151,7 @@
       </p:sp>
       <p:sp>
         <p:nvSpPr>
-          <p:cNvPr id="29" name="Text 27"/>
+          <p:cNvPr id="37" name="Text 35"/>
           <p:cNvSpPr txBox="1"/>
           <p:nvPr/>
         </p:nvSpPr>
@@ -36037,6 +36525,67 @@
         </p:nvSpPr>
         <p:spPr>
           <a:xfrm>
+            <a:off x="1938528" y="1664208"/>
+            <a:ext cx="219456" cy="219456"/>
+          </a:xfrm>
+          <a:prstGeom prst="roundRect">
+            <a:avLst>
+              <a:gd name="adj" fmla="val 28000"/>
+            </a:avLst>
+          </a:prstGeom>
+          <a:solidFill>
+            <a:srgbClr val="B5642A"/>
+          </a:solidFill>
+          <a:ln/>
+        </p:spPr>
+      </p:sp>
+      <p:sp>
+        <p:nvSpPr>
+          <p:cNvPr id="8" name="Text 6"/>
+          <p:cNvSpPr txBox="1"/>
+          <p:nvPr/>
+        </p:nvSpPr>
+        <p:spPr>
+          <a:xfrm>
+            <a:off x="1938528" y="1664208"/>
+            <a:ext cx="219456" cy="219456"/>
+          </a:xfrm>
+          <a:prstGeom prst="rect">
+            <a:avLst/>
+          </a:prstGeom>
+          <a:noFill/>
+          <a:ln/>
+        </p:spPr>
+        <p:txBody>
+          <a:bodyPr wrap="square" lIns="0" tIns="0" rIns="0" bIns="0" rtlCol="0" anchor="ctr"/>
+          <a:lstStyle/>
+          <a:p>
+            <a:pPr algn="ctr" indent="0" marL="0">
+              <a:buNone/>
+            </a:pPr>
+            <a:r>
+              <a:rPr lang="en-US" sz="600" b="1" dirty="0">
+                <a:solidFill>
+                  <a:srgbClr val="FFFFFF"/>
+                </a:solidFill>
+                <a:latin typeface="Consolas" pitchFamily="34" charset="0"/>
+                <a:ea typeface="Consolas" pitchFamily="34" charset="-122"/>
+                <a:cs typeface="Consolas" pitchFamily="34" charset="-120"/>
+              </a:rPr>
+              <a:t>LB</a:t>
+            </a:r>
+            <a:endParaRPr lang="en-US" sz="600" dirty="0"/>
+          </a:p>
+        </p:txBody>
+      </p:sp>
+      <p:sp>
+        <p:nvSpPr>
+          <p:cNvPr id="9" name="Shape 7"/>
+          <p:cNvSpPr/>
+          <p:nvPr/>
+        </p:nvSpPr>
+        <p:spPr>
+          <a:xfrm>
             <a:off x="6094476" y="2395728"/>
             <a:ext cx="9144" cy="310896"/>
           </a:xfrm>
@@ -36055,7 +36604,7 @@
       </p:sp>
       <p:sp>
         <p:nvSpPr>
-          <p:cNvPr id="8" name="Shape 6"/>
+          <p:cNvPr id="10" name="Shape 8"/>
           <p:cNvSpPr/>
           <p:nvPr/>
         </p:nvSpPr>
@@ -36082,7 +36631,7 @@
       </p:sp>
       <p:sp>
         <p:nvSpPr>
-          <p:cNvPr id="9" name="Text 7"/>
+          <p:cNvPr id="11" name="Text 9"/>
           <p:cNvSpPr txBox="1"/>
           <p:nvPr/>
         </p:nvSpPr>
@@ -36164,7 +36713,68 @@
       </p:sp>
       <p:sp>
         <p:nvSpPr>
-          <p:cNvPr id="10" name="Shape 8"/>
+          <p:cNvPr id="12" name="Shape 10"/>
+          <p:cNvSpPr/>
+          <p:nvPr/>
+        </p:nvSpPr>
+        <p:spPr>
+          <a:xfrm>
+            <a:off x="1938528" y="2816352"/>
+            <a:ext cx="219456" cy="219456"/>
+          </a:xfrm>
+          <a:prstGeom prst="roundRect">
+            <a:avLst>
+              <a:gd name="adj" fmla="val 28000"/>
+            </a:avLst>
+          </a:prstGeom>
+          <a:solidFill>
+            <a:srgbClr val="B5642A"/>
+          </a:solidFill>
+          <a:ln/>
+        </p:spPr>
+      </p:sp>
+      <p:sp>
+        <p:nvSpPr>
+          <p:cNvPr id="13" name="Text 11"/>
+          <p:cNvSpPr txBox="1"/>
+          <p:nvPr/>
+        </p:nvSpPr>
+        <p:spPr>
+          <a:xfrm>
+            <a:off x="1938528" y="2816352"/>
+            <a:ext cx="219456" cy="219456"/>
+          </a:xfrm>
+          <a:prstGeom prst="rect">
+            <a:avLst/>
+          </a:prstGeom>
+          <a:noFill/>
+          <a:ln/>
+        </p:spPr>
+        <p:txBody>
+          <a:bodyPr wrap="square" lIns="0" tIns="0" rIns="0" bIns="0" rtlCol="0" anchor="ctr"/>
+          <a:lstStyle/>
+          <a:p>
+            <a:pPr algn="ctr" indent="0" marL="0">
+              <a:buNone/>
+            </a:pPr>
+            <a:r>
+              <a:rPr lang="en-US" sz="600" b="1" dirty="0">
+                <a:solidFill>
+                  <a:srgbClr val="FFFFFF"/>
+                </a:solidFill>
+                <a:latin typeface="Consolas" pitchFamily="34" charset="0"/>
+                <a:ea typeface="Consolas" pitchFamily="34" charset="-122"/>
+                <a:cs typeface="Consolas" pitchFamily="34" charset="-120"/>
+              </a:rPr>
+              <a:t>SRV</a:t>
+            </a:r>
+            <a:endParaRPr lang="en-US" sz="600" dirty="0"/>
+          </a:p>
+        </p:txBody>
+      </p:sp>
+      <p:sp>
+        <p:nvSpPr>
+          <p:cNvPr id="14" name="Shape 12"/>
           <p:cNvSpPr/>
           <p:nvPr/>
         </p:nvSpPr>
@@ -36188,7 +36798,7 @@
       </p:sp>
       <p:sp>
         <p:nvSpPr>
-          <p:cNvPr id="11" name="Shape 9"/>
+          <p:cNvPr id="15" name="Shape 13"/>
           <p:cNvSpPr/>
           <p:nvPr/>
         </p:nvSpPr>
@@ -36215,7 +36825,7 @@
       </p:sp>
       <p:sp>
         <p:nvSpPr>
-          <p:cNvPr id="12" name="Text 10"/>
+          <p:cNvPr id="16" name="Text 14"/>
           <p:cNvSpPr txBox="1"/>
           <p:nvPr/>
         </p:nvSpPr>
@@ -36297,7 +36907,68 @@
       </p:sp>
       <p:sp>
         <p:nvSpPr>
-          <p:cNvPr id="13" name="Shape 11"/>
+          <p:cNvPr id="17" name="Shape 15"/>
+          <p:cNvSpPr/>
+          <p:nvPr/>
+        </p:nvSpPr>
+        <p:spPr>
+          <a:xfrm>
+            <a:off x="1938528" y="3968496"/>
+            <a:ext cx="219456" cy="219456"/>
+          </a:xfrm>
+          <a:prstGeom prst="roundRect">
+            <a:avLst>
+              <a:gd name="adj" fmla="val 28000"/>
+            </a:avLst>
+          </a:prstGeom>
+          <a:solidFill>
+            <a:srgbClr val="B5642A"/>
+          </a:solidFill>
+          <a:ln/>
+        </p:spPr>
+      </p:sp>
+      <p:sp>
+        <p:nvSpPr>
+          <p:cNvPr id="18" name="Text 16"/>
+          <p:cNvSpPr txBox="1"/>
+          <p:nvPr/>
+        </p:nvSpPr>
+        <p:spPr>
+          <a:xfrm>
+            <a:off x="1938528" y="3968496"/>
+            <a:ext cx="219456" cy="219456"/>
+          </a:xfrm>
+          <a:prstGeom prst="rect">
+            <a:avLst/>
+          </a:prstGeom>
+          <a:noFill/>
+          <a:ln/>
+        </p:spPr>
+        <p:txBody>
+          <a:bodyPr wrap="square" lIns="0" tIns="0" rIns="0" bIns="0" rtlCol="0" anchor="ctr"/>
+          <a:lstStyle/>
+          <a:p>
+            <a:pPr algn="ctr" indent="0" marL="0">
+              <a:buNone/>
+            </a:pPr>
+            <a:r>
+              <a:rPr lang="en-US" sz="600" b="1" dirty="0">
+                <a:solidFill>
+                  <a:srgbClr val="FFFFFF"/>
+                </a:solidFill>
+                <a:latin typeface="Consolas" pitchFamily="34" charset="0"/>
+                <a:ea typeface="Consolas" pitchFamily="34" charset="-122"/>
+                <a:cs typeface="Consolas" pitchFamily="34" charset="-120"/>
+              </a:rPr>
+              <a:t>DB</a:t>
+            </a:r>
+            <a:endParaRPr lang="en-US" sz="600" dirty="0"/>
+          </a:p>
+        </p:txBody>
+      </p:sp>
+      <p:sp>
+        <p:nvSpPr>
+          <p:cNvPr id="19" name="Shape 17"/>
           <p:cNvSpPr/>
           <p:nvPr/>
         </p:nvSpPr>
@@ -36321,7 +36992,7 @@
       </p:sp>
       <p:sp>
         <p:nvSpPr>
-          <p:cNvPr id="14" name="Shape 12"/>
+          <p:cNvPr id="20" name="Shape 18"/>
           <p:cNvSpPr/>
           <p:nvPr/>
         </p:nvSpPr>
@@ -36348,7 +37019,7 @@
       </p:sp>
       <p:sp>
         <p:nvSpPr>
-          <p:cNvPr id="15" name="Text 13"/>
+          <p:cNvPr id="21" name="Text 19"/>
           <p:cNvSpPr txBox="1"/>
           <p:nvPr/>
         </p:nvSpPr>
@@ -36430,7 +37101,68 @@
       </p:sp>
       <p:sp>
         <p:nvSpPr>
-          <p:cNvPr id="16" name="Text 14"/>
+          <p:cNvPr id="22" name="Shape 20"/>
+          <p:cNvSpPr/>
+          <p:nvPr/>
+        </p:nvSpPr>
+        <p:spPr>
+          <a:xfrm>
+            <a:off x="1938528" y="5120640"/>
+            <a:ext cx="219456" cy="219456"/>
+          </a:xfrm>
+          <a:prstGeom prst="roundRect">
+            <a:avLst>
+              <a:gd name="adj" fmla="val 28000"/>
+            </a:avLst>
+          </a:prstGeom>
+          <a:solidFill>
+            <a:srgbClr val="B5642A"/>
+          </a:solidFill>
+          <a:ln/>
+        </p:spPr>
+      </p:sp>
+      <p:sp>
+        <p:nvSpPr>
+          <p:cNvPr id="23" name="Text 21"/>
+          <p:cNvSpPr txBox="1"/>
+          <p:nvPr/>
+        </p:nvSpPr>
+        <p:spPr>
+          <a:xfrm>
+            <a:off x="1938528" y="5120640"/>
+            <a:ext cx="219456" cy="219456"/>
+          </a:xfrm>
+          <a:prstGeom prst="rect">
+            <a:avLst/>
+          </a:prstGeom>
+          <a:noFill/>
+          <a:ln/>
+        </p:spPr>
+        <p:txBody>
+          <a:bodyPr wrap="square" lIns="0" tIns="0" rIns="0" bIns="0" rtlCol="0" anchor="ctr"/>
+          <a:lstStyle/>
+          <a:p>
+            <a:pPr algn="ctr" indent="0" marL="0">
+              <a:buNone/>
+            </a:pPr>
+            <a:r>
+              <a:rPr lang="en-US" sz="600" b="1" dirty="0">
+                <a:solidFill>
+                  <a:srgbClr val="FFFFFF"/>
+                </a:solidFill>
+                <a:latin typeface="Consolas" pitchFamily="34" charset="0"/>
+                <a:ea typeface="Consolas" pitchFamily="34" charset="-122"/>
+                <a:cs typeface="Consolas" pitchFamily="34" charset="-120"/>
+              </a:rPr>
+              <a:t>BAS</a:t>
+            </a:r>
+            <a:endParaRPr lang="en-US" sz="600" dirty="0"/>
+          </a:p>
+        </p:txBody>
+      </p:sp>
+      <p:sp>
+        <p:nvSpPr>
+          <p:cNvPr id="24" name="Text 22"/>
           <p:cNvSpPr txBox="1"/>
           <p:nvPr/>
         </p:nvSpPr>
@@ -36736,6 +37468,67 @@
         </p:nvSpPr>
         <p:spPr>
           <a:xfrm>
+            <a:off x="1938528" y="1664208"/>
+            <a:ext cx="219456" cy="219456"/>
+          </a:xfrm>
+          <a:prstGeom prst="roundRect">
+            <a:avLst>
+              <a:gd name="adj" fmla="val 28000"/>
+            </a:avLst>
+          </a:prstGeom>
+          <a:solidFill>
+            <a:srgbClr val="2E6DA4"/>
+          </a:solidFill>
+          <a:ln/>
+        </p:spPr>
+      </p:sp>
+      <p:sp>
+        <p:nvSpPr>
+          <p:cNvPr id="8" name="Text 6"/>
+          <p:cNvSpPr txBox="1"/>
+          <p:nvPr/>
+        </p:nvSpPr>
+        <p:spPr>
+          <a:xfrm>
+            <a:off x="1938528" y="1664208"/>
+            <a:ext cx="219456" cy="219456"/>
+          </a:xfrm>
+          <a:prstGeom prst="rect">
+            <a:avLst/>
+          </a:prstGeom>
+          <a:noFill/>
+          <a:ln/>
+        </p:spPr>
+        <p:txBody>
+          <a:bodyPr wrap="square" lIns="0" tIns="0" rIns="0" bIns="0" rtlCol="0" anchor="ctr"/>
+          <a:lstStyle/>
+          <a:p>
+            <a:pPr algn="ctr" indent="0" marL="0">
+              <a:buNone/>
+            </a:pPr>
+            <a:r>
+              <a:rPr lang="en-US" sz="600" b="1" dirty="0">
+                <a:solidFill>
+                  <a:srgbClr val="FFFFFF"/>
+                </a:solidFill>
+                <a:latin typeface="Consolas" pitchFamily="34" charset="0"/>
+                <a:ea typeface="Consolas" pitchFamily="34" charset="-122"/>
+                <a:cs typeface="Consolas" pitchFamily="34" charset="-120"/>
+              </a:rPr>
+              <a:t>LB</a:t>
+            </a:r>
+            <a:endParaRPr lang="en-US" sz="600" dirty="0"/>
+          </a:p>
+        </p:txBody>
+      </p:sp>
+      <p:sp>
+        <p:nvSpPr>
+          <p:cNvPr id="9" name="Shape 7"/>
+          <p:cNvSpPr/>
+          <p:nvPr/>
+        </p:nvSpPr>
+        <p:spPr>
+          <a:xfrm>
             <a:off x="6094476" y="2395728"/>
             <a:ext cx="9144" cy="310896"/>
           </a:xfrm>
@@ -36754,7 +37547,7 @@
       </p:sp>
       <p:sp>
         <p:nvSpPr>
-          <p:cNvPr id="8" name="Shape 6"/>
+          <p:cNvPr id="10" name="Shape 8"/>
           <p:cNvSpPr/>
           <p:nvPr/>
         </p:nvSpPr>
@@ -36781,7 +37574,7 @@
       </p:sp>
       <p:sp>
         <p:nvSpPr>
-          <p:cNvPr id="9" name="Text 7"/>
+          <p:cNvPr id="11" name="Text 9"/>
           <p:cNvSpPr txBox="1"/>
           <p:nvPr/>
         </p:nvSpPr>
@@ -36863,7 +37656,68 @@
       </p:sp>
       <p:sp>
         <p:nvSpPr>
-          <p:cNvPr id="10" name="Shape 8"/>
+          <p:cNvPr id="12" name="Shape 10"/>
+          <p:cNvSpPr/>
+          <p:nvPr/>
+        </p:nvSpPr>
+        <p:spPr>
+          <a:xfrm>
+            <a:off x="1938528" y="2816352"/>
+            <a:ext cx="219456" cy="219456"/>
+          </a:xfrm>
+          <a:prstGeom prst="roundRect">
+            <a:avLst>
+              <a:gd name="adj" fmla="val 28000"/>
+            </a:avLst>
+          </a:prstGeom>
+          <a:solidFill>
+            <a:srgbClr val="2E6DA4"/>
+          </a:solidFill>
+          <a:ln/>
+        </p:spPr>
+      </p:sp>
+      <p:sp>
+        <p:nvSpPr>
+          <p:cNvPr id="13" name="Text 11"/>
+          <p:cNvSpPr txBox="1"/>
+          <p:nvPr/>
+        </p:nvSpPr>
+        <p:spPr>
+          <a:xfrm>
+            <a:off x="1938528" y="2816352"/>
+            <a:ext cx="219456" cy="219456"/>
+          </a:xfrm>
+          <a:prstGeom prst="rect">
+            <a:avLst/>
+          </a:prstGeom>
+          <a:noFill/>
+          <a:ln/>
+        </p:spPr>
+        <p:txBody>
+          <a:bodyPr wrap="square" lIns="0" tIns="0" rIns="0" bIns="0" rtlCol="0" anchor="ctr"/>
+          <a:lstStyle/>
+          <a:p>
+            <a:pPr algn="ctr" indent="0" marL="0">
+              <a:buNone/>
+            </a:pPr>
+            <a:r>
+              <a:rPr lang="en-US" sz="600" b="1" dirty="0">
+                <a:solidFill>
+                  <a:srgbClr val="FFFFFF"/>
+                </a:solidFill>
+                <a:latin typeface="Consolas" pitchFamily="34" charset="0"/>
+                <a:ea typeface="Consolas" pitchFamily="34" charset="-122"/>
+                <a:cs typeface="Consolas" pitchFamily="34" charset="-120"/>
+              </a:rPr>
+              <a:t>SRV</a:t>
+            </a:r>
+            <a:endParaRPr lang="en-US" sz="600" dirty="0"/>
+          </a:p>
+        </p:txBody>
+      </p:sp>
+      <p:sp>
+        <p:nvSpPr>
+          <p:cNvPr id="14" name="Shape 12"/>
           <p:cNvSpPr/>
           <p:nvPr/>
         </p:nvSpPr>
@@ -36887,7 +37741,7 @@
       </p:sp>
       <p:sp>
         <p:nvSpPr>
-          <p:cNvPr id="11" name="Shape 9"/>
+          <p:cNvPr id="15" name="Shape 13"/>
           <p:cNvSpPr/>
           <p:nvPr/>
         </p:nvSpPr>
@@ -36914,7 +37768,7 @@
       </p:sp>
       <p:sp>
         <p:nvSpPr>
-          <p:cNvPr id="12" name="Text 10"/>
+          <p:cNvPr id="16" name="Text 14"/>
           <p:cNvSpPr txBox="1"/>
           <p:nvPr/>
         </p:nvSpPr>
@@ -36996,7 +37850,68 @@
       </p:sp>
       <p:sp>
         <p:nvSpPr>
-          <p:cNvPr id="13" name="Shape 11"/>
+          <p:cNvPr id="17" name="Shape 15"/>
+          <p:cNvSpPr/>
+          <p:nvPr/>
+        </p:nvSpPr>
+        <p:spPr>
+          <a:xfrm>
+            <a:off x="1938528" y="3968496"/>
+            <a:ext cx="219456" cy="219456"/>
+          </a:xfrm>
+          <a:prstGeom prst="roundRect">
+            <a:avLst>
+              <a:gd name="adj" fmla="val 28000"/>
+            </a:avLst>
+          </a:prstGeom>
+          <a:solidFill>
+            <a:srgbClr val="2E6DA4"/>
+          </a:solidFill>
+          <a:ln/>
+        </p:spPr>
+      </p:sp>
+      <p:sp>
+        <p:nvSpPr>
+          <p:cNvPr id="18" name="Text 16"/>
+          <p:cNvSpPr txBox="1"/>
+          <p:nvPr/>
+        </p:nvSpPr>
+        <p:spPr>
+          <a:xfrm>
+            <a:off x="1938528" y="3968496"/>
+            <a:ext cx="219456" cy="219456"/>
+          </a:xfrm>
+          <a:prstGeom prst="rect">
+            <a:avLst/>
+          </a:prstGeom>
+          <a:noFill/>
+          <a:ln/>
+        </p:spPr>
+        <p:txBody>
+          <a:bodyPr wrap="square" lIns="0" tIns="0" rIns="0" bIns="0" rtlCol="0" anchor="ctr"/>
+          <a:lstStyle/>
+          <a:p>
+            <a:pPr algn="ctr" indent="0" marL="0">
+              <a:buNone/>
+            </a:pPr>
+            <a:r>
+              <a:rPr lang="en-US" sz="600" b="1" dirty="0">
+                <a:solidFill>
+                  <a:srgbClr val="FFFFFF"/>
+                </a:solidFill>
+                <a:latin typeface="Consolas" pitchFamily="34" charset="0"/>
+                <a:ea typeface="Consolas" pitchFamily="34" charset="-122"/>
+                <a:cs typeface="Consolas" pitchFamily="34" charset="-120"/>
+              </a:rPr>
+              <a:t>DB</a:t>
+            </a:r>
+            <a:endParaRPr lang="en-US" sz="600" dirty="0"/>
+          </a:p>
+        </p:txBody>
+      </p:sp>
+      <p:sp>
+        <p:nvSpPr>
+          <p:cNvPr id="19" name="Shape 17"/>
           <p:cNvSpPr/>
           <p:nvPr/>
         </p:nvSpPr>
@@ -37020,7 +37935,7 @@
       </p:sp>
       <p:sp>
         <p:nvSpPr>
-          <p:cNvPr id="14" name="Shape 12"/>
+          <p:cNvPr id="20" name="Shape 18"/>
           <p:cNvSpPr/>
           <p:nvPr/>
         </p:nvSpPr>
@@ -37047,7 +37962,7 @@
       </p:sp>
       <p:sp>
         <p:nvSpPr>
-          <p:cNvPr id="15" name="Text 13"/>
+          <p:cNvPr id="21" name="Text 19"/>
           <p:cNvSpPr txBox="1"/>
           <p:nvPr/>
         </p:nvSpPr>
@@ -37129,7 +38044,68 @@
       </p:sp>
       <p:sp>
         <p:nvSpPr>
-          <p:cNvPr id="16" name="Text 14"/>
+          <p:cNvPr id="22" name="Shape 20"/>
+          <p:cNvSpPr/>
+          <p:nvPr/>
+        </p:nvSpPr>
+        <p:spPr>
+          <a:xfrm>
+            <a:off x="1938528" y="5120640"/>
+            <a:ext cx="219456" cy="219456"/>
+          </a:xfrm>
+          <a:prstGeom prst="roundRect">
+            <a:avLst>
+              <a:gd name="adj" fmla="val 28000"/>
+            </a:avLst>
+          </a:prstGeom>
+          <a:solidFill>
+            <a:srgbClr val="2E6DA4"/>
+          </a:solidFill>
+          <a:ln/>
+        </p:spPr>
+      </p:sp>
+      <p:sp>
+        <p:nvSpPr>
+          <p:cNvPr id="23" name="Text 21"/>
+          <p:cNvSpPr txBox="1"/>
+          <p:nvPr/>
+        </p:nvSpPr>
+        <p:spPr>
+          <a:xfrm>
+            <a:off x="1938528" y="5120640"/>
+            <a:ext cx="219456" cy="219456"/>
+          </a:xfrm>
+          <a:prstGeom prst="rect">
+            <a:avLst/>
+          </a:prstGeom>
+          <a:noFill/>
+          <a:ln/>
+        </p:spPr>
+        <p:txBody>
+          <a:bodyPr wrap="square" lIns="0" tIns="0" rIns="0" bIns="0" rtlCol="0" anchor="ctr"/>
+          <a:lstStyle/>
+          <a:p>
+            <a:pPr algn="ctr" indent="0" marL="0">
+              <a:buNone/>
+            </a:pPr>
+            <a:r>
+              <a:rPr lang="en-US" sz="600" b="1" dirty="0">
+                <a:solidFill>
+                  <a:srgbClr val="FFFFFF"/>
+                </a:solidFill>
+                <a:latin typeface="Consolas" pitchFamily="34" charset="0"/>
+                <a:ea typeface="Consolas" pitchFamily="34" charset="-122"/>
+                <a:cs typeface="Consolas" pitchFamily="34" charset="-120"/>
+              </a:rPr>
+              <a:t>BAS</a:t>
+            </a:r>
+            <a:endParaRPr lang="en-US" sz="600" dirty="0"/>
+          </a:p>
+        </p:txBody>
+      </p:sp>
+      <p:sp>
+        <p:nvSpPr>
+          <p:cNvPr id="24" name="Text 22"/>
           <p:cNvSpPr txBox="1"/>
           <p:nvPr/>
         </p:nvSpPr>
@@ -37579,14 +38555,75 @@
       </p:sp>
       <p:sp>
         <p:nvSpPr>
-          <p:cNvPr id="13" name="Text 11"/>
+          <p:cNvPr id="13" name="Shape 11"/>
+          <p:cNvSpPr/>
+          <p:nvPr/>
+        </p:nvSpPr>
+        <p:spPr>
+          <a:xfrm>
+            <a:off x="969264" y="2916936"/>
+            <a:ext cx="182880" cy="182880"/>
+          </a:xfrm>
+          <a:prstGeom prst="roundRect">
+            <a:avLst>
+              <a:gd name="adj" fmla="val 28000"/>
+            </a:avLst>
+          </a:prstGeom>
+          <a:solidFill>
+            <a:srgbClr val="B5642A"/>
+          </a:solidFill>
+          <a:ln/>
+        </p:spPr>
+      </p:sp>
+      <p:sp>
+        <p:nvSpPr>
+          <p:cNvPr id="14" name="Text 12"/>
           <p:cNvSpPr txBox="1"/>
           <p:nvPr/>
         </p:nvSpPr>
         <p:spPr>
           <a:xfrm>
-            <a:off x="1005840" y="2715768"/>
-            <a:ext cx="4820260" cy="585216"/>
+            <a:off x="969264" y="2916936"/>
+            <a:ext cx="182880" cy="182880"/>
+          </a:xfrm>
+          <a:prstGeom prst="rect">
+            <a:avLst/>
+          </a:prstGeom>
+          <a:noFill/>
+          <a:ln/>
+        </p:spPr>
+        <p:txBody>
+          <a:bodyPr wrap="square" lIns="0" tIns="0" rIns="0" bIns="0" rtlCol="0" anchor="ctr"/>
+          <a:lstStyle/>
+          <a:p>
+            <a:pPr algn="ctr" indent="0" marL="0">
+              <a:buNone/>
+            </a:pPr>
+            <a:r>
+              <a:rPr lang="en-US" sz="600" b="1" dirty="0">
+                <a:solidFill>
+                  <a:srgbClr val="FFFFFF"/>
+                </a:solidFill>
+                <a:latin typeface="Consolas" pitchFamily="34" charset="0"/>
+                <a:ea typeface="Consolas" pitchFamily="34" charset="-122"/>
+                <a:cs typeface="Consolas" pitchFamily="34" charset="-120"/>
+              </a:rPr>
+              <a:t>LB</a:t>
+            </a:r>
+            <a:endParaRPr lang="en-US" sz="600" dirty="0"/>
+          </a:p>
+        </p:txBody>
+      </p:sp>
+      <p:sp>
+        <p:nvSpPr>
+          <p:cNvPr id="15" name="Text 13"/>
+          <p:cNvSpPr txBox="1"/>
+          <p:nvPr/>
+        </p:nvSpPr>
+        <p:spPr>
+          <a:xfrm>
+            <a:off x="1225296" y="2715768"/>
+            <a:ext cx="4600804" cy="585216"/>
           </a:xfrm>
           <a:prstGeom prst="rect">
             <a:avLst/>
@@ -37641,7 +38678,7 @@
       </p:sp>
       <p:sp>
         <p:nvSpPr>
-          <p:cNvPr id="14" name="Shape 12"/>
+          <p:cNvPr id="16" name="Shape 14"/>
           <p:cNvSpPr/>
           <p:nvPr/>
         </p:nvSpPr>
@@ -37663,14 +38700,75 @@
       </p:sp>
       <p:sp>
         <p:nvSpPr>
-          <p:cNvPr id="15" name="Text 13"/>
+          <p:cNvPr id="17" name="Shape 15"/>
+          <p:cNvSpPr/>
+          <p:nvPr/>
+        </p:nvSpPr>
+        <p:spPr>
+          <a:xfrm>
+            <a:off x="969264" y="3557016"/>
+            <a:ext cx="182880" cy="182880"/>
+          </a:xfrm>
+          <a:prstGeom prst="roundRect">
+            <a:avLst>
+              <a:gd name="adj" fmla="val 28000"/>
+            </a:avLst>
+          </a:prstGeom>
+          <a:solidFill>
+            <a:srgbClr val="B5642A"/>
+          </a:solidFill>
+          <a:ln/>
+        </p:spPr>
+      </p:sp>
+      <p:sp>
+        <p:nvSpPr>
+          <p:cNvPr id="18" name="Text 16"/>
           <p:cNvSpPr txBox="1"/>
           <p:nvPr/>
         </p:nvSpPr>
         <p:spPr>
           <a:xfrm>
-            <a:off x="1005840" y="3355848"/>
-            <a:ext cx="4820260" cy="585216"/>
+            <a:off x="969264" y="3557016"/>
+            <a:ext cx="182880" cy="182880"/>
+          </a:xfrm>
+          <a:prstGeom prst="rect">
+            <a:avLst/>
+          </a:prstGeom>
+          <a:noFill/>
+          <a:ln/>
+        </p:spPr>
+        <p:txBody>
+          <a:bodyPr wrap="square" lIns="0" tIns="0" rIns="0" bIns="0" rtlCol="0" anchor="ctr"/>
+          <a:lstStyle/>
+          <a:p>
+            <a:pPr algn="ctr" indent="0" marL="0">
+              <a:buNone/>
+            </a:pPr>
+            <a:r>
+              <a:rPr lang="en-US" sz="600" b="1" dirty="0">
+                <a:solidFill>
+                  <a:srgbClr val="FFFFFF"/>
+                </a:solidFill>
+                <a:latin typeface="Consolas" pitchFamily="34" charset="0"/>
+                <a:ea typeface="Consolas" pitchFamily="34" charset="-122"/>
+                <a:cs typeface="Consolas" pitchFamily="34" charset="-120"/>
+              </a:rPr>
+              <a:t>SRV</a:t>
+            </a:r>
+            <a:endParaRPr lang="en-US" sz="600" dirty="0"/>
+          </a:p>
+        </p:txBody>
+      </p:sp>
+      <p:sp>
+        <p:nvSpPr>
+          <p:cNvPr id="19" name="Text 17"/>
+          <p:cNvSpPr txBox="1"/>
+          <p:nvPr/>
+        </p:nvSpPr>
+        <p:spPr>
+          <a:xfrm>
+            <a:off x="1225296" y="3355848"/>
+            <a:ext cx="4600804" cy="585216"/>
           </a:xfrm>
           <a:prstGeom prst="rect">
             <a:avLst/>
@@ -37725,7 +38823,7 @@
       </p:sp>
       <p:sp>
         <p:nvSpPr>
-          <p:cNvPr id="16" name="Shape 14"/>
+          <p:cNvPr id="20" name="Shape 18"/>
           <p:cNvSpPr/>
           <p:nvPr/>
         </p:nvSpPr>
@@ -37747,14 +38845,75 @@
       </p:sp>
       <p:sp>
         <p:nvSpPr>
-          <p:cNvPr id="17" name="Text 15"/>
+          <p:cNvPr id="21" name="Shape 19"/>
+          <p:cNvSpPr/>
+          <p:nvPr/>
+        </p:nvSpPr>
+        <p:spPr>
+          <a:xfrm>
+            <a:off x="969264" y="4197096"/>
+            <a:ext cx="182880" cy="182880"/>
+          </a:xfrm>
+          <a:prstGeom prst="roundRect">
+            <a:avLst>
+              <a:gd name="adj" fmla="val 28000"/>
+            </a:avLst>
+          </a:prstGeom>
+          <a:solidFill>
+            <a:srgbClr val="B5642A"/>
+          </a:solidFill>
+          <a:ln/>
+        </p:spPr>
+      </p:sp>
+      <p:sp>
+        <p:nvSpPr>
+          <p:cNvPr id="22" name="Text 20"/>
           <p:cNvSpPr txBox="1"/>
           <p:nvPr/>
         </p:nvSpPr>
         <p:spPr>
           <a:xfrm>
-            <a:off x="1005840" y="3995928"/>
-            <a:ext cx="4820260" cy="585216"/>
+            <a:off x="969264" y="4197096"/>
+            <a:ext cx="182880" cy="182880"/>
+          </a:xfrm>
+          <a:prstGeom prst="rect">
+            <a:avLst/>
+          </a:prstGeom>
+          <a:noFill/>
+          <a:ln/>
+        </p:spPr>
+        <p:txBody>
+          <a:bodyPr wrap="square" lIns="0" tIns="0" rIns="0" bIns="0" rtlCol="0" anchor="ctr"/>
+          <a:lstStyle/>
+          <a:p>
+            <a:pPr algn="ctr" indent="0" marL="0">
+              <a:buNone/>
+            </a:pPr>
+            <a:r>
+              <a:rPr lang="en-US" sz="600" b="1" dirty="0">
+                <a:solidFill>
+                  <a:srgbClr val="FFFFFF"/>
+                </a:solidFill>
+                <a:latin typeface="Consolas" pitchFamily="34" charset="0"/>
+                <a:ea typeface="Consolas" pitchFamily="34" charset="-122"/>
+                <a:cs typeface="Consolas" pitchFamily="34" charset="-120"/>
+              </a:rPr>
+              <a:t>DB</a:t>
+            </a:r>
+            <a:endParaRPr lang="en-US" sz="600" dirty="0"/>
+          </a:p>
+        </p:txBody>
+      </p:sp>
+      <p:sp>
+        <p:nvSpPr>
+          <p:cNvPr id="23" name="Text 21"/>
+          <p:cNvSpPr txBox="1"/>
+          <p:nvPr/>
+        </p:nvSpPr>
+        <p:spPr>
+          <a:xfrm>
+            <a:off x="1225296" y="3995928"/>
+            <a:ext cx="4600804" cy="585216"/>
           </a:xfrm>
           <a:prstGeom prst="rect">
             <a:avLst/>
@@ -37809,7 +38968,7 @@
       </p:sp>
       <p:sp>
         <p:nvSpPr>
-          <p:cNvPr id="18" name="Shape 16"/>
+          <p:cNvPr id="24" name="Shape 22"/>
           <p:cNvSpPr/>
           <p:nvPr/>
         </p:nvSpPr>
@@ -37836,7 +38995,7 @@
       </p:sp>
       <p:sp>
         <p:nvSpPr>
-          <p:cNvPr id="19" name="Text 17"/>
+          <p:cNvPr id="25" name="Text 23"/>
           <p:cNvSpPr txBox="1"/>
           <p:nvPr/>
         </p:nvSpPr>
@@ -37875,7 +39034,7 @@
       </p:sp>
       <p:sp>
         <p:nvSpPr>
-          <p:cNvPr id="20" name="Shape 18"/>
+          <p:cNvPr id="26" name="Shape 24"/>
           <p:cNvSpPr/>
           <p:nvPr/>
         </p:nvSpPr>
@@ -37897,14 +39056,75 @@
       </p:sp>
       <p:sp>
         <p:nvSpPr>
-          <p:cNvPr id="21" name="Text 19"/>
+          <p:cNvPr id="27" name="Shape 25"/>
+          <p:cNvSpPr/>
+          <p:nvPr/>
+        </p:nvSpPr>
+        <p:spPr>
+          <a:xfrm>
+            <a:off x="6329020" y="2916936"/>
+            <a:ext cx="182880" cy="182880"/>
+          </a:xfrm>
+          <a:prstGeom prst="roundRect">
+            <a:avLst>
+              <a:gd name="adj" fmla="val 28000"/>
+            </a:avLst>
+          </a:prstGeom>
+          <a:solidFill>
+            <a:srgbClr val="B5642A"/>
+          </a:solidFill>
+          <a:ln/>
+        </p:spPr>
+      </p:sp>
+      <p:sp>
+        <p:nvSpPr>
+          <p:cNvPr id="28" name="Text 26"/>
           <p:cNvSpPr txBox="1"/>
           <p:nvPr/>
         </p:nvSpPr>
         <p:spPr>
           <a:xfrm>
-            <a:off x="6365596" y="2715768"/>
-            <a:ext cx="4820260" cy="585216"/>
+            <a:off x="6329020" y="2916936"/>
+            <a:ext cx="182880" cy="182880"/>
+          </a:xfrm>
+          <a:prstGeom prst="rect">
+            <a:avLst/>
+          </a:prstGeom>
+          <a:noFill/>
+          <a:ln/>
+        </p:spPr>
+        <p:txBody>
+          <a:bodyPr wrap="square" lIns="0" tIns="0" rIns="0" bIns="0" rtlCol="0" anchor="ctr"/>
+          <a:lstStyle/>
+          <a:p>
+            <a:pPr algn="ctr" indent="0" marL="0">
+              <a:buNone/>
+            </a:pPr>
+            <a:r>
+              <a:rPr lang="en-US" sz="600" b="1" dirty="0">
+                <a:solidFill>
+                  <a:srgbClr val="FFFFFF"/>
+                </a:solidFill>
+                <a:latin typeface="Consolas" pitchFamily="34" charset="0"/>
+                <a:ea typeface="Consolas" pitchFamily="34" charset="-122"/>
+                <a:cs typeface="Consolas" pitchFamily="34" charset="-120"/>
+              </a:rPr>
+              <a:t>LB</a:t>
+            </a:r>
+            <a:endParaRPr lang="en-US" sz="600" dirty="0"/>
+          </a:p>
+        </p:txBody>
+      </p:sp>
+      <p:sp>
+        <p:nvSpPr>
+          <p:cNvPr id="29" name="Text 27"/>
+          <p:cNvSpPr txBox="1"/>
+          <p:nvPr/>
+        </p:nvSpPr>
+        <p:spPr>
+          <a:xfrm>
+            <a:off x="6585052" y="2715768"/>
+            <a:ext cx="4600804" cy="585216"/>
           </a:xfrm>
           <a:prstGeom prst="rect">
             <a:avLst/>
@@ -37959,7 +39179,7 @@
       </p:sp>
       <p:sp>
         <p:nvSpPr>
-          <p:cNvPr id="22" name="Shape 20"/>
+          <p:cNvPr id="30" name="Shape 28"/>
           <p:cNvSpPr/>
           <p:nvPr/>
         </p:nvSpPr>
@@ -37981,14 +39201,75 @@
       </p:sp>
       <p:sp>
         <p:nvSpPr>
-          <p:cNvPr id="23" name="Text 21"/>
+          <p:cNvPr id="31" name="Shape 29"/>
+          <p:cNvSpPr/>
+          <p:nvPr/>
+        </p:nvSpPr>
+        <p:spPr>
+          <a:xfrm>
+            <a:off x="6329020" y="3557016"/>
+            <a:ext cx="182880" cy="182880"/>
+          </a:xfrm>
+          <a:prstGeom prst="roundRect">
+            <a:avLst>
+              <a:gd name="adj" fmla="val 28000"/>
+            </a:avLst>
+          </a:prstGeom>
+          <a:solidFill>
+            <a:srgbClr val="B5642A"/>
+          </a:solidFill>
+          <a:ln/>
+        </p:spPr>
+      </p:sp>
+      <p:sp>
+        <p:nvSpPr>
+          <p:cNvPr id="32" name="Text 30"/>
           <p:cNvSpPr txBox="1"/>
           <p:nvPr/>
         </p:nvSpPr>
         <p:spPr>
           <a:xfrm>
-            <a:off x="6365596" y="3355848"/>
-            <a:ext cx="4820260" cy="585216"/>
+            <a:off x="6329020" y="3557016"/>
+            <a:ext cx="182880" cy="182880"/>
+          </a:xfrm>
+          <a:prstGeom prst="rect">
+            <a:avLst/>
+          </a:prstGeom>
+          <a:noFill/>
+          <a:ln/>
+        </p:spPr>
+        <p:txBody>
+          <a:bodyPr wrap="square" lIns="0" tIns="0" rIns="0" bIns="0" rtlCol="0" anchor="ctr"/>
+          <a:lstStyle/>
+          <a:p>
+            <a:pPr algn="ctr" indent="0" marL="0">
+              <a:buNone/>
+            </a:pPr>
+            <a:r>
+              <a:rPr lang="en-US" sz="600" b="1" dirty="0">
+                <a:solidFill>
+                  <a:srgbClr val="FFFFFF"/>
+                </a:solidFill>
+                <a:latin typeface="Consolas" pitchFamily="34" charset="0"/>
+                <a:ea typeface="Consolas" pitchFamily="34" charset="-122"/>
+                <a:cs typeface="Consolas" pitchFamily="34" charset="-120"/>
+              </a:rPr>
+              <a:t>SRV</a:t>
+            </a:r>
+            <a:endParaRPr lang="en-US" sz="600" dirty="0"/>
+          </a:p>
+        </p:txBody>
+      </p:sp>
+      <p:sp>
+        <p:nvSpPr>
+          <p:cNvPr id="33" name="Text 31"/>
+          <p:cNvSpPr txBox="1"/>
+          <p:nvPr/>
+        </p:nvSpPr>
+        <p:spPr>
+          <a:xfrm>
+            <a:off x="6585052" y="3355848"/>
+            <a:ext cx="4600804" cy="585216"/>
           </a:xfrm>
           <a:prstGeom prst="rect">
             <a:avLst/>
@@ -38043,7 +39324,7 @@
       </p:sp>
       <p:sp>
         <p:nvSpPr>
-          <p:cNvPr id="24" name="Shape 22"/>
+          <p:cNvPr id="34" name="Shape 32"/>
           <p:cNvSpPr/>
           <p:nvPr/>
         </p:nvSpPr>
@@ -38065,14 +39346,75 @@
       </p:sp>
       <p:sp>
         <p:nvSpPr>
-          <p:cNvPr id="25" name="Text 23"/>
+          <p:cNvPr id="35" name="Shape 33"/>
+          <p:cNvSpPr/>
+          <p:nvPr/>
+        </p:nvSpPr>
+        <p:spPr>
+          <a:xfrm>
+            <a:off x="6329020" y="4197096"/>
+            <a:ext cx="182880" cy="182880"/>
+          </a:xfrm>
+          <a:prstGeom prst="roundRect">
+            <a:avLst>
+              <a:gd name="adj" fmla="val 28000"/>
+            </a:avLst>
+          </a:prstGeom>
+          <a:solidFill>
+            <a:srgbClr val="B5642A"/>
+          </a:solidFill>
+          <a:ln/>
+        </p:spPr>
+      </p:sp>
+      <p:sp>
+        <p:nvSpPr>
+          <p:cNvPr id="36" name="Text 34"/>
           <p:cNvSpPr txBox="1"/>
           <p:nvPr/>
         </p:nvSpPr>
         <p:spPr>
           <a:xfrm>
-            <a:off x="6365596" y="3995928"/>
-            <a:ext cx="4820260" cy="585216"/>
+            <a:off x="6329020" y="4197096"/>
+            <a:ext cx="182880" cy="182880"/>
+          </a:xfrm>
+          <a:prstGeom prst="rect">
+            <a:avLst/>
+          </a:prstGeom>
+          <a:noFill/>
+          <a:ln/>
+        </p:spPr>
+        <p:txBody>
+          <a:bodyPr wrap="square" lIns="0" tIns="0" rIns="0" bIns="0" rtlCol="0" anchor="ctr"/>
+          <a:lstStyle/>
+          <a:p>
+            <a:pPr algn="ctr" indent="0" marL="0">
+              <a:buNone/>
+            </a:pPr>
+            <a:r>
+              <a:rPr lang="en-US" sz="600" b="1" dirty="0">
+                <a:solidFill>
+                  <a:srgbClr val="FFFFFF"/>
+                </a:solidFill>
+                <a:latin typeface="Consolas" pitchFamily="34" charset="0"/>
+                <a:ea typeface="Consolas" pitchFamily="34" charset="-122"/>
+                <a:cs typeface="Consolas" pitchFamily="34" charset="-120"/>
+              </a:rPr>
+              <a:t>DB</a:t>
+            </a:r>
+            <a:endParaRPr lang="en-US" sz="600" dirty="0"/>
+          </a:p>
+        </p:txBody>
+      </p:sp>
+      <p:sp>
+        <p:nvSpPr>
+          <p:cNvPr id="37" name="Text 35"/>
+          <p:cNvSpPr txBox="1"/>
+          <p:nvPr/>
+        </p:nvSpPr>
+        <p:spPr>
+          <a:xfrm>
+            <a:off x="6585052" y="3995928"/>
+            <a:ext cx="4600804" cy="585216"/>
           </a:xfrm>
           <a:prstGeom prst="rect">
             <a:avLst/>
@@ -38127,7 +39469,7 @@
       </p:sp>
       <p:sp>
         <p:nvSpPr>
-          <p:cNvPr id="26" name="Shape 24"/>
+          <p:cNvPr id="38" name="Shape 36"/>
           <p:cNvSpPr/>
           <p:nvPr/>
         </p:nvSpPr>
@@ -38149,14 +39491,75 @@
       </p:sp>
       <p:sp>
         <p:nvSpPr>
-          <p:cNvPr id="27" name="Text 25"/>
+          <p:cNvPr id="39" name="Shape 37"/>
+          <p:cNvSpPr/>
+          <p:nvPr/>
+        </p:nvSpPr>
+        <p:spPr>
+          <a:xfrm>
+            <a:off x="914400" y="5015484"/>
+            <a:ext cx="201168" cy="201168"/>
+          </a:xfrm>
+          <a:prstGeom prst="roundRect">
+            <a:avLst>
+              <a:gd name="adj" fmla="val 28000"/>
+            </a:avLst>
+          </a:prstGeom>
+          <a:solidFill>
+            <a:srgbClr val="B5642A"/>
+          </a:solidFill>
+          <a:ln/>
+        </p:spPr>
+      </p:sp>
+      <p:sp>
+        <p:nvSpPr>
+          <p:cNvPr id="40" name="Text 38"/>
           <p:cNvSpPr txBox="1"/>
           <p:nvPr/>
         </p:nvSpPr>
         <p:spPr>
           <a:xfrm>
-            <a:off x="914400" y="4864608"/>
-            <a:ext cx="10362895" cy="502920"/>
+            <a:off x="914400" y="5015484"/>
+            <a:ext cx="201168" cy="201168"/>
+          </a:xfrm>
+          <a:prstGeom prst="rect">
+            <a:avLst/>
+          </a:prstGeom>
+          <a:noFill/>
+          <a:ln/>
+        </p:spPr>
+        <p:txBody>
+          <a:bodyPr wrap="square" lIns="0" tIns="0" rIns="0" bIns="0" rtlCol="0" anchor="ctr"/>
+          <a:lstStyle/>
+          <a:p>
+            <a:pPr algn="ctr" indent="0" marL="0">
+              <a:buNone/>
+            </a:pPr>
+            <a:r>
+              <a:rPr lang="en-US" sz="600" b="1" dirty="0">
+                <a:solidFill>
+                  <a:srgbClr val="FFFFFF"/>
+                </a:solidFill>
+                <a:latin typeface="Consolas" pitchFamily="34" charset="0"/>
+                <a:ea typeface="Consolas" pitchFamily="34" charset="-122"/>
+                <a:cs typeface="Consolas" pitchFamily="34" charset="-120"/>
+              </a:rPr>
+              <a:t>BAS</a:t>
+            </a:r>
+            <a:endParaRPr lang="en-US" sz="600" dirty="0"/>
+          </a:p>
+        </p:txBody>
+      </p:sp>
+      <p:sp>
+        <p:nvSpPr>
+          <p:cNvPr id="41" name="Text 39"/>
+          <p:cNvSpPr txBox="1"/>
+          <p:nvPr/>
+        </p:nvSpPr>
+        <p:spPr>
+          <a:xfrm>
+            <a:off x="1188720" y="4864608"/>
+            <a:ext cx="10088575" cy="502920"/>
           </a:xfrm>
           <a:prstGeom prst="rect">
             <a:avLst/>
@@ -38191,7 +39594,7 @@
       </p:sp>
       <p:sp>
         <p:nvSpPr>
-          <p:cNvPr id="28" name="Shape 26"/>
+          <p:cNvPr id="42" name="Shape 40"/>
           <p:cNvSpPr/>
           <p:nvPr/>
         </p:nvSpPr>
@@ -38218,7 +39621,7 @@
       </p:sp>
       <p:sp>
         <p:nvSpPr>
-          <p:cNvPr id="29" name="Text 27"/>
+          <p:cNvPr id="43" name="Text 41"/>
           <p:cNvSpPr txBox="1"/>
           <p:nvPr/>
         </p:nvSpPr>
@@ -38257,7 +39660,7 @@
       </p:sp>
       <p:sp>
         <p:nvSpPr>
-          <p:cNvPr id="30" name="Text 28"/>
+          <p:cNvPr id="44" name="Text 42"/>
           <p:cNvSpPr txBox="1"/>
           <p:nvPr/>
         </p:nvSpPr>
@@ -38707,14 +40110,75 @@
       </p:sp>
       <p:sp>
         <p:nvSpPr>
-          <p:cNvPr id="13" name="Text 11"/>
+          <p:cNvPr id="13" name="Shape 11"/>
+          <p:cNvSpPr/>
+          <p:nvPr/>
+        </p:nvSpPr>
+        <p:spPr>
+          <a:xfrm>
+            <a:off x="969264" y="2916936"/>
+            <a:ext cx="182880" cy="182880"/>
+          </a:xfrm>
+          <a:prstGeom prst="roundRect">
+            <a:avLst>
+              <a:gd name="adj" fmla="val 28000"/>
+            </a:avLst>
+          </a:prstGeom>
+          <a:solidFill>
+            <a:srgbClr val="2E6DA4"/>
+          </a:solidFill>
+          <a:ln/>
+        </p:spPr>
+      </p:sp>
+      <p:sp>
+        <p:nvSpPr>
+          <p:cNvPr id="14" name="Text 12"/>
           <p:cNvSpPr txBox="1"/>
           <p:nvPr/>
         </p:nvSpPr>
         <p:spPr>
           <a:xfrm>
-            <a:off x="1005840" y="2715768"/>
-            <a:ext cx="4820260" cy="585216"/>
+            <a:off x="969264" y="2916936"/>
+            <a:ext cx="182880" cy="182880"/>
+          </a:xfrm>
+          <a:prstGeom prst="rect">
+            <a:avLst/>
+          </a:prstGeom>
+          <a:noFill/>
+          <a:ln/>
+        </p:spPr>
+        <p:txBody>
+          <a:bodyPr wrap="square" lIns="0" tIns="0" rIns="0" bIns="0" rtlCol="0" anchor="ctr"/>
+          <a:lstStyle/>
+          <a:p>
+            <a:pPr algn="ctr" indent="0" marL="0">
+              <a:buNone/>
+            </a:pPr>
+            <a:r>
+              <a:rPr lang="en-US" sz="600" b="1" dirty="0">
+                <a:solidFill>
+                  <a:srgbClr val="FFFFFF"/>
+                </a:solidFill>
+                <a:latin typeface="Consolas" pitchFamily="34" charset="0"/>
+                <a:ea typeface="Consolas" pitchFamily="34" charset="-122"/>
+                <a:cs typeface="Consolas" pitchFamily="34" charset="-120"/>
+              </a:rPr>
+              <a:t>LB</a:t>
+            </a:r>
+            <a:endParaRPr lang="en-US" sz="600" dirty="0"/>
+          </a:p>
+        </p:txBody>
+      </p:sp>
+      <p:sp>
+        <p:nvSpPr>
+          <p:cNvPr id="15" name="Text 13"/>
+          <p:cNvSpPr txBox="1"/>
+          <p:nvPr/>
+        </p:nvSpPr>
+        <p:spPr>
+          <a:xfrm>
+            <a:off x="1225296" y="2715768"/>
+            <a:ext cx="4600804" cy="585216"/>
           </a:xfrm>
           <a:prstGeom prst="rect">
             <a:avLst/>
@@ -38769,7 +40233,7 @@
       </p:sp>
       <p:sp>
         <p:nvSpPr>
-          <p:cNvPr id="14" name="Shape 12"/>
+          <p:cNvPr id="16" name="Shape 14"/>
           <p:cNvSpPr/>
           <p:nvPr/>
         </p:nvSpPr>
@@ -38791,14 +40255,75 @@
       </p:sp>
       <p:sp>
         <p:nvSpPr>
-          <p:cNvPr id="15" name="Text 13"/>
+          <p:cNvPr id="17" name="Shape 15"/>
+          <p:cNvSpPr/>
+          <p:nvPr/>
+        </p:nvSpPr>
+        <p:spPr>
+          <a:xfrm>
+            <a:off x="969264" y="3557016"/>
+            <a:ext cx="182880" cy="182880"/>
+          </a:xfrm>
+          <a:prstGeom prst="roundRect">
+            <a:avLst>
+              <a:gd name="adj" fmla="val 28000"/>
+            </a:avLst>
+          </a:prstGeom>
+          <a:solidFill>
+            <a:srgbClr val="2E6DA4"/>
+          </a:solidFill>
+          <a:ln/>
+        </p:spPr>
+      </p:sp>
+      <p:sp>
+        <p:nvSpPr>
+          <p:cNvPr id="18" name="Text 16"/>
           <p:cNvSpPr txBox="1"/>
           <p:nvPr/>
         </p:nvSpPr>
         <p:spPr>
           <a:xfrm>
-            <a:off x="1005840" y="3355848"/>
-            <a:ext cx="4820260" cy="585216"/>
+            <a:off x="969264" y="3557016"/>
+            <a:ext cx="182880" cy="182880"/>
+          </a:xfrm>
+          <a:prstGeom prst="rect">
+            <a:avLst/>
+          </a:prstGeom>
+          <a:noFill/>
+          <a:ln/>
+        </p:spPr>
+        <p:txBody>
+          <a:bodyPr wrap="square" lIns="0" tIns="0" rIns="0" bIns="0" rtlCol="0" anchor="ctr"/>
+          <a:lstStyle/>
+          <a:p>
+            <a:pPr algn="ctr" indent="0" marL="0">
+              <a:buNone/>
+            </a:pPr>
+            <a:r>
+              <a:rPr lang="en-US" sz="600" b="1" dirty="0">
+                <a:solidFill>
+                  <a:srgbClr val="FFFFFF"/>
+                </a:solidFill>
+                <a:latin typeface="Consolas" pitchFamily="34" charset="0"/>
+                <a:ea typeface="Consolas" pitchFamily="34" charset="-122"/>
+                <a:cs typeface="Consolas" pitchFamily="34" charset="-120"/>
+              </a:rPr>
+              <a:t>SRV</a:t>
+            </a:r>
+            <a:endParaRPr lang="en-US" sz="600" dirty="0"/>
+          </a:p>
+        </p:txBody>
+      </p:sp>
+      <p:sp>
+        <p:nvSpPr>
+          <p:cNvPr id="19" name="Text 17"/>
+          <p:cNvSpPr txBox="1"/>
+          <p:nvPr/>
+        </p:nvSpPr>
+        <p:spPr>
+          <a:xfrm>
+            <a:off x="1225296" y="3355848"/>
+            <a:ext cx="4600804" cy="585216"/>
           </a:xfrm>
           <a:prstGeom prst="rect">
             <a:avLst/>
@@ -38853,7 +40378,7 @@
       </p:sp>
       <p:sp>
         <p:nvSpPr>
-          <p:cNvPr id="16" name="Shape 14"/>
+          <p:cNvPr id="20" name="Shape 18"/>
           <p:cNvSpPr/>
           <p:nvPr/>
         </p:nvSpPr>
@@ -38875,14 +40400,75 @@
       </p:sp>
       <p:sp>
         <p:nvSpPr>
-          <p:cNvPr id="17" name="Text 15"/>
+          <p:cNvPr id="21" name="Shape 19"/>
+          <p:cNvSpPr/>
+          <p:nvPr/>
+        </p:nvSpPr>
+        <p:spPr>
+          <a:xfrm>
+            <a:off x="969264" y="4197096"/>
+            <a:ext cx="182880" cy="182880"/>
+          </a:xfrm>
+          <a:prstGeom prst="roundRect">
+            <a:avLst>
+              <a:gd name="adj" fmla="val 28000"/>
+            </a:avLst>
+          </a:prstGeom>
+          <a:solidFill>
+            <a:srgbClr val="2E6DA4"/>
+          </a:solidFill>
+          <a:ln/>
+        </p:spPr>
+      </p:sp>
+      <p:sp>
+        <p:nvSpPr>
+          <p:cNvPr id="22" name="Text 20"/>
           <p:cNvSpPr txBox="1"/>
           <p:nvPr/>
         </p:nvSpPr>
         <p:spPr>
           <a:xfrm>
-            <a:off x="1005840" y="3995928"/>
-            <a:ext cx="4820260" cy="585216"/>
+            <a:off x="969264" y="4197096"/>
+            <a:ext cx="182880" cy="182880"/>
+          </a:xfrm>
+          <a:prstGeom prst="rect">
+            <a:avLst/>
+          </a:prstGeom>
+          <a:noFill/>
+          <a:ln/>
+        </p:spPr>
+        <p:txBody>
+          <a:bodyPr wrap="square" lIns="0" tIns="0" rIns="0" bIns="0" rtlCol="0" anchor="ctr"/>
+          <a:lstStyle/>
+          <a:p>
+            <a:pPr algn="ctr" indent="0" marL="0">
+              <a:buNone/>
+            </a:pPr>
+            <a:r>
+              <a:rPr lang="en-US" sz="600" b="1" dirty="0">
+                <a:solidFill>
+                  <a:srgbClr val="FFFFFF"/>
+                </a:solidFill>
+                <a:latin typeface="Consolas" pitchFamily="34" charset="0"/>
+                <a:ea typeface="Consolas" pitchFamily="34" charset="-122"/>
+                <a:cs typeface="Consolas" pitchFamily="34" charset="-120"/>
+              </a:rPr>
+              <a:t>DB</a:t>
+            </a:r>
+            <a:endParaRPr lang="en-US" sz="600" dirty="0"/>
+          </a:p>
+        </p:txBody>
+      </p:sp>
+      <p:sp>
+        <p:nvSpPr>
+          <p:cNvPr id="23" name="Text 21"/>
+          <p:cNvSpPr txBox="1"/>
+          <p:nvPr/>
+        </p:nvSpPr>
+        <p:spPr>
+          <a:xfrm>
+            <a:off x="1225296" y="3995928"/>
+            <a:ext cx="4600804" cy="585216"/>
           </a:xfrm>
           <a:prstGeom prst="rect">
             <a:avLst/>
@@ -38937,7 +40523,7 @@
       </p:sp>
       <p:sp>
         <p:nvSpPr>
-          <p:cNvPr id="18" name="Shape 16"/>
+          <p:cNvPr id="24" name="Shape 22"/>
           <p:cNvSpPr/>
           <p:nvPr/>
         </p:nvSpPr>
@@ -38964,7 +40550,7 @@
       </p:sp>
       <p:sp>
         <p:nvSpPr>
-          <p:cNvPr id="19" name="Text 17"/>
+          <p:cNvPr id="25" name="Text 23"/>
           <p:cNvSpPr txBox="1"/>
           <p:nvPr/>
         </p:nvSpPr>
@@ -39003,7 +40589,7 @@
       </p:sp>
       <p:sp>
         <p:nvSpPr>
-          <p:cNvPr id="20" name="Shape 18"/>
+          <p:cNvPr id="26" name="Shape 24"/>
           <p:cNvSpPr/>
           <p:nvPr/>
         </p:nvSpPr>
@@ -39025,14 +40611,75 @@
       </p:sp>
       <p:sp>
         <p:nvSpPr>
-          <p:cNvPr id="21" name="Text 19"/>
+          <p:cNvPr id="27" name="Shape 25"/>
+          <p:cNvSpPr/>
+          <p:nvPr/>
+        </p:nvSpPr>
+        <p:spPr>
+          <a:xfrm>
+            <a:off x="6329020" y="2916936"/>
+            <a:ext cx="182880" cy="182880"/>
+          </a:xfrm>
+          <a:prstGeom prst="roundRect">
+            <a:avLst>
+              <a:gd name="adj" fmla="val 28000"/>
+            </a:avLst>
+          </a:prstGeom>
+          <a:solidFill>
+            <a:srgbClr val="2E6DA4"/>
+          </a:solidFill>
+          <a:ln/>
+        </p:spPr>
+      </p:sp>
+      <p:sp>
+        <p:nvSpPr>
+          <p:cNvPr id="28" name="Text 26"/>
           <p:cNvSpPr txBox="1"/>
           <p:nvPr/>
         </p:nvSpPr>
         <p:spPr>
           <a:xfrm>
-            <a:off x="6365596" y="2715768"/>
-            <a:ext cx="4820260" cy="585216"/>
+            <a:off x="6329020" y="2916936"/>
+            <a:ext cx="182880" cy="182880"/>
+          </a:xfrm>
+          <a:prstGeom prst="rect">
+            <a:avLst/>
+          </a:prstGeom>
+          <a:noFill/>
+          <a:ln/>
+        </p:spPr>
+        <p:txBody>
+          <a:bodyPr wrap="square" lIns="0" tIns="0" rIns="0" bIns="0" rtlCol="0" anchor="ctr"/>
+          <a:lstStyle/>
+          <a:p>
+            <a:pPr algn="ctr" indent="0" marL="0">
+              <a:buNone/>
+            </a:pPr>
+            <a:r>
+              <a:rPr lang="en-US" sz="600" b="1" dirty="0">
+                <a:solidFill>
+                  <a:srgbClr val="FFFFFF"/>
+                </a:solidFill>
+                <a:latin typeface="Consolas" pitchFamily="34" charset="0"/>
+                <a:ea typeface="Consolas" pitchFamily="34" charset="-122"/>
+                <a:cs typeface="Consolas" pitchFamily="34" charset="-120"/>
+              </a:rPr>
+              <a:t>LB</a:t>
+            </a:r>
+            <a:endParaRPr lang="en-US" sz="600" dirty="0"/>
+          </a:p>
+        </p:txBody>
+      </p:sp>
+      <p:sp>
+        <p:nvSpPr>
+          <p:cNvPr id="29" name="Text 27"/>
+          <p:cNvSpPr txBox="1"/>
+          <p:nvPr/>
+        </p:nvSpPr>
+        <p:spPr>
+          <a:xfrm>
+            <a:off x="6585052" y="2715768"/>
+            <a:ext cx="4600804" cy="585216"/>
           </a:xfrm>
           <a:prstGeom prst="rect">
             <a:avLst/>
@@ -39087,7 +40734,7 @@
       </p:sp>
       <p:sp>
         <p:nvSpPr>
-          <p:cNvPr id="22" name="Shape 20"/>
+          <p:cNvPr id="30" name="Shape 28"/>
           <p:cNvSpPr/>
           <p:nvPr/>
         </p:nvSpPr>
@@ -39109,14 +40756,75 @@
       </p:sp>
       <p:sp>
         <p:nvSpPr>
-          <p:cNvPr id="23" name="Text 21"/>
+          <p:cNvPr id="31" name="Shape 29"/>
+          <p:cNvSpPr/>
+          <p:nvPr/>
+        </p:nvSpPr>
+        <p:spPr>
+          <a:xfrm>
+            <a:off x="6329020" y="3557016"/>
+            <a:ext cx="182880" cy="182880"/>
+          </a:xfrm>
+          <a:prstGeom prst="roundRect">
+            <a:avLst>
+              <a:gd name="adj" fmla="val 28000"/>
+            </a:avLst>
+          </a:prstGeom>
+          <a:solidFill>
+            <a:srgbClr val="2E6DA4"/>
+          </a:solidFill>
+          <a:ln/>
+        </p:spPr>
+      </p:sp>
+      <p:sp>
+        <p:nvSpPr>
+          <p:cNvPr id="32" name="Text 30"/>
           <p:cNvSpPr txBox="1"/>
           <p:nvPr/>
         </p:nvSpPr>
         <p:spPr>
           <a:xfrm>
-            <a:off x="6365596" y="3355848"/>
-            <a:ext cx="4820260" cy="585216"/>
+            <a:off x="6329020" y="3557016"/>
+            <a:ext cx="182880" cy="182880"/>
+          </a:xfrm>
+          <a:prstGeom prst="rect">
+            <a:avLst/>
+          </a:prstGeom>
+          <a:noFill/>
+          <a:ln/>
+        </p:spPr>
+        <p:txBody>
+          <a:bodyPr wrap="square" lIns="0" tIns="0" rIns="0" bIns="0" rtlCol="0" anchor="ctr"/>
+          <a:lstStyle/>
+          <a:p>
+            <a:pPr algn="ctr" indent="0" marL="0">
+              <a:buNone/>
+            </a:pPr>
+            <a:r>
+              <a:rPr lang="en-US" sz="600" b="1" dirty="0">
+                <a:solidFill>
+                  <a:srgbClr val="FFFFFF"/>
+                </a:solidFill>
+                <a:latin typeface="Consolas" pitchFamily="34" charset="0"/>
+                <a:ea typeface="Consolas" pitchFamily="34" charset="-122"/>
+                <a:cs typeface="Consolas" pitchFamily="34" charset="-120"/>
+              </a:rPr>
+              <a:t>SRV</a:t>
+            </a:r>
+            <a:endParaRPr lang="en-US" sz="600" dirty="0"/>
+          </a:p>
+        </p:txBody>
+      </p:sp>
+      <p:sp>
+        <p:nvSpPr>
+          <p:cNvPr id="33" name="Text 31"/>
+          <p:cNvSpPr txBox="1"/>
+          <p:nvPr/>
+        </p:nvSpPr>
+        <p:spPr>
+          <a:xfrm>
+            <a:off x="6585052" y="3355848"/>
+            <a:ext cx="4600804" cy="585216"/>
           </a:xfrm>
           <a:prstGeom prst="rect">
             <a:avLst/>
@@ -39171,7 +40879,7 @@
       </p:sp>
       <p:sp>
         <p:nvSpPr>
-          <p:cNvPr id="24" name="Shape 22"/>
+          <p:cNvPr id="34" name="Shape 32"/>
           <p:cNvSpPr/>
           <p:nvPr/>
         </p:nvSpPr>
@@ -39193,14 +40901,75 @@
       </p:sp>
       <p:sp>
         <p:nvSpPr>
-          <p:cNvPr id="25" name="Text 23"/>
+          <p:cNvPr id="35" name="Shape 33"/>
+          <p:cNvSpPr/>
+          <p:nvPr/>
+        </p:nvSpPr>
+        <p:spPr>
+          <a:xfrm>
+            <a:off x="6329020" y="4197096"/>
+            <a:ext cx="182880" cy="182880"/>
+          </a:xfrm>
+          <a:prstGeom prst="roundRect">
+            <a:avLst>
+              <a:gd name="adj" fmla="val 28000"/>
+            </a:avLst>
+          </a:prstGeom>
+          <a:solidFill>
+            <a:srgbClr val="2E6DA4"/>
+          </a:solidFill>
+          <a:ln/>
+        </p:spPr>
+      </p:sp>
+      <p:sp>
+        <p:nvSpPr>
+          <p:cNvPr id="36" name="Text 34"/>
           <p:cNvSpPr txBox="1"/>
           <p:nvPr/>
         </p:nvSpPr>
         <p:spPr>
           <a:xfrm>
-            <a:off x="6365596" y="3995928"/>
-            <a:ext cx="4820260" cy="585216"/>
+            <a:off x="6329020" y="4197096"/>
+            <a:ext cx="182880" cy="182880"/>
+          </a:xfrm>
+          <a:prstGeom prst="rect">
+            <a:avLst/>
+          </a:prstGeom>
+          <a:noFill/>
+          <a:ln/>
+        </p:spPr>
+        <p:txBody>
+          <a:bodyPr wrap="square" lIns="0" tIns="0" rIns="0" bIns="0" rtlCol="0" anchor="ctr"/>
+          <a:lstStyle/>
+          <a:p>
+            <a:pPr algn="ctr" indent="0" marL="0">
+              <a:buNone/>
+            </a:pPr>
+            <a:r>
+              <a:rPr lang="en-US" sz="600" b="1" dirty="0">
+                <a:solidFill>
+                  <a:srgbClr val="FFFFFF"/>
+                </a:solidFill>
+                <a:latin typeface="Consolas" pitchFamily="34" charset="0"/>
+                <a:ea typeface="Consolas" pitchFamily="34" charset="-122"/>
+                <a:cs typeface="Consolas" pitchFamily="34" charset="-120"/>
+              </a:rPr>
+              <a:t>DB</a:t>
+            </a:r>
+            <a:endParaRPr lang="en-US" sz="600" dirty="0"/>
+          </a:p>
+        </p:txBody>
+      </p:sp>
+      <p:sp>
+        <p:nvSpPr>
+          <p:cNvPr id="37" name="Text 35"/>
+          <p:cNvSpPr txBox="1"/>
+          <p:nvPr/>
+        </p:nvSpPr>
+        <p:spPr>
+          <a:xfrm>
+            <a:off x="6585052" y="3995928"/>
+            <a:ext cx="4600804" cy="585216"/>
           </a:xfrm>
           <a:prstGeom prst="rect">
             <a:avLst/>
@@ -39255,7 +41024,7 @@
       </p:sp>
       <p:sp>
         <p:nvSpPr>
-          <p:cNvPr id="26" name="Shape 24"/>
+          <p:cNvPr id="38" name="Shape 36"/>
           <p:cNvSpPr/>
           <p:nvPr/>
         </p:nvSpPr>
@@ -39277,14 +41046,75 @@
       </p:sp>
       <p:sp>
         <p:nvSpPr>
-          <p:cNvPr id="27" name="Text 25"/>
+          <p:cNvPr id="39" name="Shape 37"/>
+          <p:cNvSpPr/>
+          <p:nvPr/>
+        </p:nvSpPr>
+        <p:spPr>
+          <a:xfrm>
+            <a:off x="914400" y="5015484"/>
+            <a:ext cx="201168" cy="201168"/>
+          </a:xfrm>
+          <a:prstGeom prst="roundRect">
+            <a:avLst>
+              <a:gd name="adj" fmla="val 28000"/>
+            </a:avLst>
+          </a:prstGeom>
+          <a:solidFill>
+            <a:srgbClr val="2E6DA4"/>
+          </a:solidFill>
+          <a:ln/>
+        </p:spPr>
+      </p:sp>
+      <p:sp>
+        <p:nvSpPr>
+          <p:cNvPr id="40" name="Text 38"/>
           <p:cNvSpPr txBox="1"/>
           <p:nvPr/>
         </p:nvSpPr>
         <p:spPr>
           <a:xfrm>
-            <a:off x="914400" y="4864608"/>
-            <a:ext cx="10362895" cy="502920"/>
+            <a:off x="914400" y="5015484"/>
+            <a:ext cx="201168" cy="201168"/>
+          </a:xfrm>
+          <a:prstGeom prst="rect">
+            <a:avLst/>
+          </a:prstGeom>
+          <a:noFill/>
+          <a:ln/>
+        </p:spPr>
+        <p:txBody>
+          <a:bodyPr wrap="square" lIns="0" tIns="0" rIns="0" bIns="0" rtlCol="0" anchor="ctr"/>
+          <a:lstStyle/>
+          <a:p>
+            <a:pPr algn="ctr" indent="0" marL="0">
+              <a:buNone/>
+            </a:pPr>
+            <a:r>
+              <a:rPr lang="en-US" sz="600" b="1" dirty="0">
+                <a:solidFill>
+                  <a:srgbClr val="FFFFFF"/>
+                </a:solidFill>
+                <a:latin typeface="Consolas" pitchFamily="34" charset="0"/>
+                <a:ea typeface="Consolas" pitchFamily="34" charset="-122"/>
+                <a:cs typeface="Consolas" pitchFamily="34" charset="-120"/>
+              </a:rPr>
+              <a:t>BAS</a:t>
+            </a:r>
+            <a:endParaRPr lang="en-US" sz="600" dirty="0"/>
+          </a:p>
+        </p:txBody>
+      </p:sp>
+      <p:sp>
+        <p:nvSpPr>
+          <p:cNvPr id="41" name="Text 39"/>
+          <p:cNvSpPr txBox="1"/>
+          <p:nvPr/>
+        </p:nvSpPr>
+        <p:spPr>
+          <a:xfrm>
+            <a:off x="1188720" y="4864608"/>
+            <a:ext cx="10088575" cy="502920"/>
           </a:xfrm>
           <a:prstGeom prst="rect">
             <a:avLst/>
@@ -39319,7 +41149,7 @@
       </p:sp>
       <p:sp>
         <p:nvSpPr>
-          <p:cNvPr id="28" name="Shape 26"/>
+          <p:cNvPr id="42" name="Shape 40"/>
           <p:cNvSpPr/>
           <p:nvPr/>
         </p:nvSpPr>
@@ -39346,7 +41176,7 @@
       </p:sp>
       <p:sp>
         <p:nvSpPr>
-          <p:cNvPr id="29" name="Text 27"/>
+          <p:cNvPr id="43" name="Text 41"/>
           <p:cNvSpPr txBox="1"/>
           <p:nvPr/>
         </p:nvSpPr>
@@ -39385,7 +41215,7 @@
       </p:sp>
       <p:sp>
         <p:nvSpPr>
-          <p:cNvPr id="30" name="Text 28"/>
+          <p:cNvPr id="44" name="Text 42"/>
           <p:cNvSpPr txBox="1"/>
           <p:nvPr/>
         </p:nvSpPr>

</xml_diff>